<commit_message>
feat: complete PPT — original 12 slides + 4 AKI comparison slides with our upgrades
</commit_message>
<xml_diff>
--- a/output/LLM_Wiki_OpenClaw_Obsidian_完整版.pptx
+++ b/output/LLM_Wiki_OpenClaw_Obsidian_完整版.pptx
@@ -8206,7 +8206,7 @@
         <p:spPr>
           <a:xfrm>
             <a:off x="0" y="0"/>
-            <a:ext cx="12188952" cy="1005840"/>
+            <a:ext cx="12188952" cy="822960"/>
           </a:xfrm>
           <a:prstGeom prst="rect">
             <a:avLst/>
@@ -8248,34 +8248,67 @@
         </p:nvSpPr>
         <p:spPr>
           <a:xfrm>
-            <a:off x="457200" y="137160"/>
-            <a:ext cx="10972800" cy="731520"/>
-          </a:xfrm>
-          <a:prstGeom prst="rect">
-            <a:avLst/>
-          </a:prstGeom>
-          <a:noFill/>
-        </p:spPr>
-        <p:txBody>
-          <a:bodyPr wrap="none">
-            <a:spAutoFit/>
-          </a:bodyPr>
-          <a:lstStyle/>
-          <a:p>
-            <a:r>
-              <a:rPr sz="2600" b="1">
+            <a:off x="365760" y="91440"/>
+            <a:ext cx="7315200" cy="640080"/>
+          </a:xfrm>
+          <a:prstGeom prst="rect">
+            <a:avLst/>
+          </a:prstGeom>
+          <a:noFill/>
+        </p:spPr>
+        <p:txBody>
+          <a:bodyPr wrap="square">
+            <a:spAutoFit/>
+          </a:bodyPr>
+          <a:lstStyle/>
+          <a:p>
+            <a:r>
+              <a:rPr sz="2200" b="1" i="0">
                 <a:solidFill>
                   <a:srgbClr val="6C5CF5"/>
                 </a:solidFill>
               </a:rPr>
               <a:t>📊 Karpathy 三层架构</a:t>
+            </a:r>
+          </a:p>
+        </p:txBody>
+      </p:sp>
+      <p:sp>
+        <p:nvSpPr>
+          <p:cNvPr id="4" name="TextBox 3"/>
+          <p:cNvSpPr txBox="1"/>
+          <p:nvPr/>
+        </p:nvSpPr>
+        <p:spPr>
+          <a:xfrm>
+            <a:off x="7772400" y="137160"/>
+            <a:ext cx="4114800" cy="548640"/>
+          </a:xfrm>
+          <a:prstGeom prst="rect">
+            <a:avLst/>
+          </a:prstGeom>
+          <a:noFill/>
+        </p:spPr>
+        <p:txBody>
+          <a:bodyPr wrap="square">
+            <a:spAutoFit/>
+          </a:bodyPr>
+          <a:lstStyle/>
+          <a:p>
+            <a:r>
+              <a:rPr sz="1300" b="0" i="0">
+                <a:solidFill>
+                  <a:srgbClr val="AAAABB"/>
+                </a:solidFill>
+              </a:rPr>
+              <a:t>图里方案 vs 咱们方案</a:t>
             </a:r>
           </a:p>
         </p:txBody>
       </p:sp>
       <p:pic>
         <p:nvPicPr>
-          <p:cNvPr id="4" name="Picture 3" descr="知识库参考图_1_Karpathy三层架构.jpg"/>
+          <p:cNvPr id="5" name="Picture 4" descr="知识库参考图_1_Karpathy三层架构.jpg"/>
           <p:cNvPicPr>
             <a:picLocks noChangeAspect="1"/>
           </p:cNvPicPr>
@@ -8289,8 +8322,8 @@
         </p:blipFill>
         <p:spPr>
           <a:xfrm>
-            <a:off x="274320" y="1188720"/>
-            <a:ext cx="11612880" cy="4846320"/>
+            <a:off x="182880" y="914400"/>
+            <a:ext cx="6583680" cy="5669280"/>
           </a:xfrm>
           <a:prstGeom prst="rect">
             <a:avLst/>
@@ -8299,14 +8332,635 @@
       </p:pic>
       <p:sp>
         <p:nvSpPr>
-          <p:cNvPr id="5" name="Rectangle 4"/>
+          <p:cNvPr id="6" name="Rectangle 5"/>
           <p:cNvSpPr/>
           <p:nvPr/>
         </p:nvSpPr>
         <p:spPr>
           <a:xfrm>
-            <a:off x="0" y="6217920"/>
-            <a:ext cx="12188952" cy="640080"/>
+            <a:off x="6903720" y="914400"/>
+            <a:ext cx="36576" cy="5669280"/>
+          </a:xfrm>
+          <a:prstGeom prst="rect">
+            <a:avLst/>
+          </a:prstGeom>
+          <a:solidFill>
+            <a:srgbClr val="4A4A7A"/>
+          </a:solidFill>
+          <a:ln>
+            <a:noFill/>
+          </a:ln>
+        </p:spPr>
+        <p:style>
+          <a:lnRef idx="1">
+            <a:schemeClr val="accent1"/>
+          </a:lnRef>
+          <a:fillRef idx="3">
+            <a:schemeClr val="accent1"/>
+          </a:fillRef>
+          <a:effectRef idx="2">
+            <a:schemeClr val="accent1"/>
+          </a:effectRef>
+          <a:fontRef idx="minor">
+            <a:schemeClr val="lt1"/>
+          </a:fontRef>
+        </p:style>
+        <p:txBody>
+          <a:bodyPr rtlCol="0" anchor="ctr"/>
+          <a:lstStyle/>
+          <a:p>
+            <a:pPr algn="ctr"/>
+          </a:p>
+        </p:txBody>
+      </p:sp>
+      <p:sp>
+        <p:nvSpPr>
+          <p:cNvPr id="7" name="Rectangle 6"/>
+          <p:cNvSpPr/>
+          <p:nvPr/>
+        </p:nvSpPr>
+        <p:spPr>
+          <a:xfrm>
+            <a:off x="6949440" y="914400"/>
+            <a:ext cx="5120640" cy="457200"/>
+          </a:xfrm>
+          <a:prstGeom prst="rect">
+            <a:avLst/>
+          </a:prstGeom>
+          <a:solidFill>
+            <a:srgbClr val="1E1E3E"/>
+          </a:solidFill>
+          <a:ln>
+            <a:noFill/>
+          </a:ln>
+        </p:spPr>
+        <p:style>
+          <a:lnRef idx="1">
+            <a:schemeClr val="accent1"/>
+          </a:lnRef>
+          <a:fillRef idx="3">
+            <a:schemeClr val="accent1"/>
+          </a:fillRef>
+          <a:effectRef idx="2">
+            <a:schemeClr val="accent1"/>
+          </a:effectRef>
+          <a:fontRef idx="minor">
+            <a:schemeClr val="lt1"/>
+          </a:fontRef>
+        </p:style>
+        <p:txBody>
+          <a:bodyPr rtlCol="0" anchor="ctr"/>
+          <a:lstStyle/>
+          <a:p>
+            <a:pPr algn="ctr"/>
+          </a:p>
+        </p:txBody>
+      </p:sp>
+      <p:sp>
+        <p:nvSpPr>
+          <p:cNvPr id="8" name="TextBox 7"/>
+          <p:cNvSpPr txBox="1"/>
+          <p:nvPr/>
+        </p:nvSpPr>
+        <p:spPr>
+          <a:xfrm>
+            <a:off x="7040880" y="960120"/>
+            <a:ext cx="4846320" cy="365760"/>
+          </a:xfrm>
+          <a:prstGeom prst="rect">
+            <a:avLst/>
+          </a:prstGeom>
+          <a:noFill/>
+        </p:spPr>
+        <p:txBody>
+          <a:bodyPr wrap="square">
+            <a:spAutoFit/>
+          </a:bodyPr>
+          <a:lstStyle/>
+          <a:p>
+            <a:r>
+              <a:rPr sz="1300" b="1" i="0">
+                <a:solidFill>
+                  <a:srgbClr val="4EFF9C"/>
+                </a:solidFill>
+              </a:rPr>
+              <a:t>🚀 咱们方案的升级点</a:t>
+            </a:r>
+          </a:p>
+        </p:txBody>
+      </p:sp>
+      <p:sp>
+        <p:nvSpPr>
+          <p:cNvPr id="9" name="Rectangle 8"/>
+          <p:cNvSpPr/>
+          <p:nvPr/>
+        </p:nvSpPr>
+        <p:spPr>
+          <a:xfrm>
+            <a:off x="6949440" y="1417320"/>
+            <a:ext cx="5120640" cy="411480"/>
+          </a:xfrm>
+          <a:prstGeom prst="rect">
+            <a:avLst/>
+          </a:prstGeom>
+          <a:solidFill>
+            <a:srgbClr val="222244"/>
+          </a:solidFill>
+          <a:ln>
+            <a:noFill/>
+          </a:ln>
+        </p:spPr>
+        <p:style>
+          <a:lnRef idx="1">
+            <a:schemeClr val="accent1"/>
+          </a:lnRef>
+          <a:fillRef idx="3">
+            <a:schemeClr val="accent1"/>
+          </a:fillRef>
+          <a:effectRef idx="2">
+            <a:schemeClr val="accent1"/>
+          </a:effectRef>
+          <a:fontRef idx="minor">
+            <a:schemeClr val="lt1"/>
+          </a:fontRef>
+        </p:style>
+        <p:txBody>
+          <a:bodyPr rtlCol="0" anchor="ctr"/>
+          <a:lstStyle/>
+          <a:p>
+            <a:pPr algn="ctr"/>
+          </a:p>
+        </p:txBody>
+      </p:sp>
+      <p:sp>
+        <p:nvSpPr>
+          <p:cNvPr id="10" name="TextBox 9"/>
+          <p:cNvSpPr txBox="1"/>
+          <p:nvPr/>
+        </p:nvSpPr>
+        <p:spPr>
+          <a:xfrm>
+            <a:off x="7040880" y="1463040"/>
+            <a:ext cx="4846320" cy="320040"/>
+          </a:xfrm>
+          <a:prstGeom prst="rect">
+            <a:avLst/>
+          </a:prstGeom>
+          <a:noFill/>
+        </p:spPr>
+        <p:txBody>
+          <a:bodyPr wrap="square">
+            <a:spAutoFit/>
+          </a:bodyPr>
+          <a:lstStyle/>
+          <a:p>
+            <a:r>
+              <a:rPr sz="1100" b="0" i="0">
+                <a:solidFill>
+                  <a:srgbClr val="AAAABB"/>
+                </a:solidFill>
+              </a:rPr>
+              <a:t>Raw/Wiki/Schema 层级结构</a:t>
+            </a:r>
+          </a:p>
+        </p:txBody>
+      </p:sp>
+      <p:sp>
+        <p:nvSpPr>
+          <p:cNvPr id="11" name="Rectangle 10"/>
+          <p:cNvSpPr/>
+          <p:nvPr/>
+        </p:nvSpPr>
+        <p:spPr>
+          <a:xfrm>
+            <a:off x="6949440" y="1920240"/>
+            <a:ext cx="5120640" cy="347472"/>
+          </a:xfrm>
+          <a:prstGeom prst="rect">
+            <a:avLst/>
+          </a:prstGeom>
+          <a:solidFill>
+            <a:srgbClr val="2A2A55"/>
+          </a:solidFill>
+          <a:ln>
+            <a:noFill/>
+          </a:ln>
+        </p:spPr>
+        <p:style>
+          <a:lnRef idx="1">
+            <a:schemeClr val="accent1"/>
+          </a:lnRef>
+          <a:fillRef idx="3">
+            <a:schemeClr val="accent1"/>
+          </a:fillRef>
+          <a:effectRef idx="2">
+            <a:schemeClr val="accent1"/>
+          </a:effectRef>
+          <a:fontRef idx="minor">
+            <a:schemeClr val="lt1"/>
+          </a:fontRef>
+        </p:style>
+        <p:txBody>
+          <a:bodyPr rtlCol="0" anchor="ctr"/>
+          <a:lstStyle/>
+          <a:p>
+            <a:pPr algn="ctr"/>
+          </a:p>
+        </p:txBody>
+      </p:sp>
+      <p:sp>
+        <p:nvSpPr>
+          <p:cNvPr id="12" name="TextBox 11"/>
+          <p:cNvSpPr txBox="1"/>
+          <p:nvPr/>
+        </p:nvSpPr>
+        <p:spPr>
+          <a:xfrm>
+            <a:off x="6995160" y="1938528"/>
+            <a:ext cx="5029200" cy="310896"/>
+          </a:xfrm>
+          <a:prstGeom prst="rect">
+            <a:avLst/>
+          </a:prstGeom>
+          <a:noFill/>
+        </p:spPr>
+        <p:txBody>
+          <a:bodyPr wrap="square">
+            <a:spAutoFit/>
+          </a:bodyPr>
+          <a:lstStyle/>
+          <a:p>
+            <a:r>
+              <a:rPr sz="1200" b="1" i="0">
+                <a:solidFill>
+                  <a:srgbClr val="6C5CF5"/>
+                </a:solidFill>
+              </a:rPr>
+              <a:t>  1. 自动化 ingest</a:t>
+            </a:r>
+          </a:p>
+        </p:txBody>
+      </p:sp>
+      <p:sp>
+        <p:nvSpPr>
+          <p:cNvPr id="13" name="TextBox 12"/>
+          <p:cNvSpPr txBox="1"/>
+          <p:nvPr/>
+        </p:nvSpPr>
+        <p:spPr>
+          <a:xfrm>
+            <a:off x="7040880" y="2286000"/>
+            <a:ext cx="5029200" cy="320040"/>
+          </a:xfrm>
+          <a:prstGeom prst="rect">
+            <a:avLst/>
+          </a:prstGeom>
+          <a:noFill/>
+        </p:spPr>
+        <p:txBody>
+          <a:bodyPr wrap="square">
+            <a:spAutoFit/>
+          </a:bodyPr>
+          <a:lstStyle/>
+          <a:p>
+            <a:r>
+              <a:rPr sz="1100" b="0" i="0">
+                <a:solidFill>
+                  <a:srgbClr val="E0E0FF"/>
+                </a:solidFill>
+              </a:rPr>
+              <a:t>    图里手动整理raw</a:t>
+            </a:r>
+          </a:p>
+        </p:txBody>
+      </p:sp>
+      <p:sp>
+        <p:nvSpPr>
+          <p:cNvPr id="14" name="TextBox 13"/>
+          <p:cNvSpPr txBox="1"/>
+          <p:nvPr/>
+        </p:nvSpPr>
+        <p:spPr>
+          <a:xfrm>
+            <a:off x="7040880" y="2633472"/>
+            <a:ext cx="5029200" cy="320040"/>
+          </a:xfrm>
+          <a:prstGeom prst="rect">
+            <a:avLst/>
+          </a:prstGeom>
+          <a:noFill/>
+        </p:spPr>
+        <p:txBody>
+          <a:bodyPr wrap="square">
+            <a:spAutoFit/>
+          </a:bodyPr>
+          <a:lstStyle/>
+          <a:p>
+            <a:r>
+              <a:rPr sz="1100" b="0" i="0">
+                <a:solidFill>
+                  <a:srgbClr val="E0E0FF"/>
+                </a:solidFill>
+              </a:rPr>
+              <a:t>    咱们 auto_ingest 自动生成 summary</a:t>
+            </a:r>
+          </a:p>
+        </p:txBody>
+      </p:sp>
+      <p:sp>
+        <p:nvSpPr>
+          <p:cNvPr id="15" name="Rectangle 14"/>
+          <p:cNvSpPr/>
+          <p:nvPr/>
+        </p:nvSpPr>
+        <p:spPr>
+          <a:xfrm>
+            <a:off x="6949440" y="3072384"/>
+            <a:ext cx="5120640" cy="347472"/>
+          </a:xfrm>
+          <a:prstGeom prst="rect">
+            <a:avLst/>
+          </a:prstGeom>
+          <a:solidFill>
+            <a:srgbClr val="2A2A55"/>
+          </a:solidFill>
+          <a:ln>
+            <a:noFill/>
+          </a:ln>
+        </p:spPr>
+        <p:style>
+          <a:lnRef idx="1">
+            <a:schemeClr val="accent1"/>
+          </a:lnRef>
+          <a:fillRef idx="3">
+            <a:schemeClr val="accent1"/>
+          </a:fillRef>
+          <a:effectRef idx="2">
+            <a:schemeClr val="accent1"/>
+          </a:effectRef>
+          <a:fontRef idx="minor">
+            <a:schemeClr val="lt1"/>
+          </a:fontRef>
+        </p:style>
+        <p:txBody>
+          <a:bodyPr rtlCol="0" anchor="ctr"/>
+          <a:lstStyle/>
+          <a:p>
+            <a:pPr algn="ctr"/>
+          </a:p>
+        </p:txBody>
+      </p:sp>
+      <p:sp>
+        <p:nvSpPr>
+          <p:cNvPr id="16" name="TextBox 15"/>
+          <p:cNvSpPr txBox="1"/>
+          <p:nvPr/>
+        </p:nvSpPr>
+        <p:spPr>
+          <a:xfrm>
+            <a:off x="6995160" y="3090672"/>
+            <a:ext cx="5029200" cy="310896"/>
+          </a:xfrm>
+          <a:prstGeom prst="rect">
+            <a:avLst/>
+          </a:prstGeom>
+          <a:noFill/>
+        </p:spPr>
+        <p:txBody>
+          <a:bodyPr wrap="square">
+            <a:spAutoFit/>
+          </a:bodyPr>
+          <a:lstStyle/>
+          <a:p>
+            <a:r>
+              <a:rPr sz="1200" b="1" i="0">
+                <a:solidFill>
+                  <a:srgbClr val="6C5CF5"/>
+                </a:solidFill>
+              </a:rPr>
+              <a:t>  2. 持续运营</a:t>
+            </a:r>
+          </a:p>
+        </p:txBody>
+      </p:sp>
+      <p:sp>
+        <p:nvSpPr>
+          <p:cNvPr id="17" name="TextBox 16"/>
+          <p:cNvSpPr txBox="1"/>
+          <p:nvPr/>
+        </p:nvSpPr>
+        <p:spPr>
+          <a:xfrm>
+            <a:off x="7040880" y="3438144"/>
+            <a:ext cx="5029200" cy="320040"/>
+          </a:xfrm>
+          <a:prstGeom prst="rect">
+            <a:avLst/>
+          </a:prstGeom>
+          <a:noFill/>
+        </p:spPr>
+        <p:txBody>
+          <a:bodyPr wrap="square">
+            <a:spAutoFit/>
+          </a:bodyPr>
+          <a:lstStyle/>
+          <a:p>
+            <a:r>
+              <a:rPr sz="1100" b="0" i="0">
+                <a:solidFill>
+                  <a:srgbClr val="E0E0FF"/>
+                </a:solidFill>
+              </a:rPr>
+              <a:t>    图里偏静态</a:t>
+            </a:r>
+          </a:p>
+        </p:txBody>
+      </p:sp>
+      <p:sp>
+        <p:nvSpPr>
+          <p:cNvPr id="18" name="TextBox 17"/>
+          <p:cNvSpPr txBox="1"/>
+          <p:nvPr/>
+        </p:nvSpPr>
+        <p:spPr>
+          <a:xfrm>
+            <a:off x="7040880" y="3785615"/>
+            <a:ext cx="5029200" cy="320040"/>
+          </a:xfrm>
+          <a:prstGeom prst="rect">
+            <a:avLst/>
+          </a:prstGeom>
+          <a:noFill/>
+        </p:spPr>
+        <p:txBody>
+          <a:bodyPr wrap="square">
+            <a:spAutoFit/>
+          </a:bodyPr>
+          <a:lstStyle/>
+          <a:p>
+            <a:r>
+              <a:rPr sz="1100" b="0" i="0">
+                <a:solidFill>
+                  <a:srgbClr val="E0E0FF"/>
+                </a:solidFill>
+              </a:rPr>
+              <a:t>    咱们 Cron 自动检测新文件、lint 健康检查</a:t>
+            </a:r>
+          </a:p>
+        </p:txBody>
+      </p:sp>
+      <p:sp>
+        <p:nvSpPr>
+          <p:cNvPr id="19" name="Rectangle 18"/>
+          <p:cNvSpPr/>
+          <p:nvPr/>
+        </p:nvSpPr>
+        <p:spPr>
+          <a:xfrm>
+            <a:off x="6949440" y="4224527"/>
+            <a:ext cx="5120640" cy="347472"/>
+          </a:xfrm>
+          <a:prstGeom prst="rect">
+            <a:avLst/>
+          </a:prstGeom>
+          <a:solidFill>
+            <a:srgbClr val="2A2A55"/>
+          </a:solidFill>
+          <a:ln>
+            <a:noFill/>
+          </a:ln>
+        </p:spPr>
+        <p:style>
+          <a:lnRef idx="1">
+            <a:schemeClr val="accent1"/>
+          </a:lnRef>
+          <a:fillRef idx="3">
+            <a:schemeClr val="accent1"/>
+          </a:fillRef>
+          <a:effectRef idx="2">
+            <a:schemeClr val="accent1"/>
+          </a:effectRef>
+          <a:fontRef idx="minor">
+            <a:schemeClr val="lt1"/>
+          </a:fontRef>
+        </p:style>
+        <p:txBody>
+          <a:bodyPr rtlCol="0" anchor="ctr"/>
+          <a:lstStyle/>
+          <a:p>
+            <a:pPr algn="ctr"/>
+          </a:p>
+        </p:txBody>
+      </p:sp>
+      <p:sp>
+        <p:nvSpPr>
+          <p:cNvPr id="20" name="TextBox 19"/>
+          <p:cNvSpPr txBox="1"/>
+          <p:nvPr/>
+        </p:nvSpPr>
+        <p:spPr>
+          <a:xfrm>
+            <a:off x="6995160" y="4242815"/>
+            <a:ext cx="5029200" cy="310896"/>
+          </a:xfrm>
+          <a:prstGeom prst="rect">
+            <a:avLst/>
+          </a:prstGeom>
+          <a:noFill/>
+        </p:spPr>
+        <p:txBody>
+          <a:bodyPr wrap="square">
+            <a:spAutoFit/>
+          </a:bodyPr>
+          <a:lstStyle/>
+          <a:p>
+            <a:r>
+              <a:rPr sz="1200" b="1" i="0">
+                <a:solidFill>
+                  <a:srgbClr val="6C5CF5"/>
+                </a:solidFill>
+              </a:rPr>
+              <a:t>  3. Schema 督导</a:t>
+            </a:r>
+          </a:p>
+        </p:txBody>
+      </p:sp>
+      <p:sp>
+        <p:nvSpPr>
+          <p:cNvPr id="21" name="TextBox 20"/>
+          <p:cNvSpPr txBox="1"/>
+          <p:nvPr/>
+        </p:nvSpPr>
+        <p:spPr>
+          <a:xfrm>
+            <a:off x="7040880" y="4590288"/>
+            <a:ext cx="5029200" cy="320040"/>
+          </a:xfrm>
+          <a:prstGeom prst="rect">
+            <a:avLst/>
+          </a:prstGeom>
+          <a:noFill/>
+        </p:spPr>
+        <p:txBody>
+          <a:bodyPr wrap="square">
+            <a:spAutoFit/>
+          </a:bodyPr>
+          <a:lstStyle/>
+          <a:p>
+            <a:r>
+              <a:rPr sz="1100" b="0" i="0">
+                <a:solidFill>
+                  <a:srgbClr val="E0E0FF"/>
+                </a:solidFill>
+              </a:rPr>
+              <a:t>    CLAUDE.md 定义规则</a:t>
+            </a:r>
+          </a:p>
+        </p:txBody>
+      </p:sp>
+      <p:sp>
+        <p:nvSpPr>
+          <p:cNvPr id="22" name="TextBox 21"/>
+          <p:cNvSpPr txBox="1"/>
+          <p:nvPr/>
+        </p:nvSpPr>
+        <p:spPr>
+          <a:xfrm>
+            <a:off x="7040880" y="4937759"/>
+            <a:ext cx="5029200" cy="320040"/>
+          </a:xfrm>
+          <a:prstGeom prst="rect">
+            <a:avLst/>
+          </a:prstGeom>
+          <a:noFill/>
+        </p:spPr>
+        <p:txBody>
+          <a:bodyPr wrap="square">
+            <a:spAutoFit/>
+          </a:bodyPr>
+          <a:lstStyle/>
+          <a:p>
+            <a:r>
+              <a:rPr sz="1100" b="0" i="0">
+                <a:solidFill>
+                  <a:srgbClr val="E0E0FF"/>
+                </a:solidFill>
+              </a:rPr>
+              <a:t>    但治理机制待完善</a:t>
+            </a:r>
+          </a:p>
+        </p:txBody>
+      </p:sp>
+      <p:sp>
+        <p:nvSpPr>
+          <p:cNvPr id="23" name="Rectangle 22"/>
+          <p:cNvSpPr/>
+          <p:nvPr/>
+        </p:nvSpPr>
+        <p:spPr>
+          <a:xfrm>
+            <a:off x="0" y="6583680"/>
+            <a:ext cx="12188952" cy="274320"/>
           </a:xfrm>
           <a:prstGeom prst="rect">
             <a:avLst/>
@@ -8342,33 +8996,33 @@
       </p:sp>
       <p:sp>
         <p:nvSpPr>
-          <p:cNvPr id="6" name="TextBox 5"/>
-          <p:cNvSpPr txBox="1"/>
-          <p:nvPr/>
-        </p:nvSpPr>
-        <p:spPr>
-          <a:xfrm>
-            <a:off x="457200" y="6263640"/>
-            <a:ext cx="10972800" cy="457200"/>
-          </a:xfrm>
-          <a:prstGeom prst="rect">
-            <a:avLst/>
-          </a:prstGeom>
-          <a:noFill/>
-        </p:spPr>
-        <p:txBody>
-          <a:bodyPr wrap="none">
-            <a:spAutoFit/>
-          </a:bodyPr>
-          <a:lstStyle/>
-          <a:p>
-            <a:r>
-              <a:rPr sz="1400">
+          <p:cNvPr id="24" name="TextBox 23"/>
+          <p:cNvSpPr txBox="1"/>
+          <p:nvPr/>
+        </p:nvSpPr>
+        <p:spPr>
+          <a:xfrm>
+            <a:off x="365760" y="6601968"/>
+            <a:ext cx="10972800" cy="228600"/>
+          </a:xfrm>
+          <a:prstGeom prst="rect">
+            <a:avLst/>
+          </a:prstGeom>
+          <a:noFill/>
+        </p:spPr>
+        <p:txBody>
+          <a:bodyPr wrap="square">
+            <a:spAutoFit/>
+          </a:bodyPr>
+          <a:lstStyle/>
+          <a:p>
+            <a:r>
+              <a:rPr sz="1000" b="0" i="0">
                 <a:solidFill>
                   <a:srgbClr val="AAAABB"/>
                 </a:solidFill>
               </a:rPr>
-              <a:t>底层：Raw Materials | 中层：Wiki Layer | 顶层：Schema Layer</a:t>
+              <a:t>来源：Aki聊AI  |  对比：咱们方案</a:t>
             </a:r>
           </a:p>
         </p:txBody>
@@ -8408,7 +9062,7 @@
         <p:spPr>
           <a:xfrm>
             <a:off x="0" y="0"/>
-            <a:ext cx="12188952" cy="1005840"/>
+            <a:ext cx="12188952" cy="822960"/>
           </a:xfrm>
           <a:prstGeom prst="rect">
             <a:avLst/>
@@ -8450,34 +9104,67 @@
         </p:nvSpPr>
         <p:spPr>
           <a:xfrm>
-            <a:off x="457200" y="137160"/>
-            <a:ext cx="10972800" cy="731520"/>
-          </a:xfrm>
-          <a:prstGeom prst="rect">
-            <a:avLst/>
-          </a:prstGeom>
-          <a:noFill/>
-        </p:spPr>
-        <p:txBody>
-          <a:bodyPr wrap="none">
-            <a:spAutoFit/>
-          </a:bodyPr>
-          <a:lstStyle/>
-          <a:p>
-            <a:r>
-              <a:rPr sz="2600" b="1">
+            <a:off x="365760" y="91440"/>
+            <a:ext cx="7315200" cy="640080"/>
+          </a:xfrm>
+          <a:prstGeom prst="rect">
+            <a:avLst/>
+          </a:prstGeom>
+          <a:noFill/>
+        </p:spPr>
+        <p:txBody>
+          <a:bodyPr wrap="square">
+            <a:spAutoFit/>
+          </a:bodyPr>
+          <a:lstStyle/>
+          <a:p>
+            <a:r>
+              <a:rPr sz="2200" b="1" i="0">
                 <a:solidFill>
                   <a:srgbClr val="6C5CF5"/>
                 </a:solidFill>
               </a:rPr>
               <a:t>📊 四工具工作流</a:t>
+            </a:r>
+          </a:p>
+        </p:txBody>
+      </p:sp>
+      <p:sp>
+        <p:nvSpPr>
+          <p:cNvPr id="4" name="TextBox 3"/>
+          <p:cNvSpPr txBox="1"/>
+          <p:nvPr/>
+        </p:nvSpPr>
+        <p:spPr>
+          <a:xfrm>
+            <a:off x="7772400" y="137160"/>
+            <a:ext cx="4114800" cy="548640"/>
+          </a:xfrm>
+          <a:prstGeom prst="rect">
+            <a:avLst/>
+          </a:prstGeom>
+          <a:noFill/>
+        </p:spPr>
+        <p:txBody>
+          <a:bodyPr wrap="square">
+            <a:spAutoFit/>
+          </a:bodyPr>
+          <a:lstStyle/>
+          <a:p>
+            <a:r>
+              <a:rPr sz="1300" b="0" i="0">
+                <a:solidFill>
+                  <a:srgbClr val="AAAABB"/>
+                </a:solidFill>
+              </a:rPr>
+              <a:t>图里方案 vs 咱们方案</a:t>
             </a:r>
           </a:p>
         </p:txBody>
       </p:sp>
       <p:pic>
         <p:nvPicPr>
-          <p:cNvPr id="4" name="Picture 3" descr="知识库参考图_1_Karpathy三层架构.jpg"/>
+          <p:cNvPr id="5" name="Picture 4" descr="知识库参考图_1_Karpathy三层架构.jpg"/>
           <p:cNvPicPr>
             <a:picLocks noChangeAspect="1"/>
           </p:cNvPicPr>
@@ -8491,8 +9178,8 @@
         </p:blipFill>
         <p:spPr>
           <a:xfrm>
-            <a:off x="274320" y="1188720"/>
-            <a:ext cx="11612880" cy="4846320"/>
+            <a:off x="182880" y="914400"/>
+            <a:ext cx="6583680" cy="5669280"/>
           </a:xfrm>
           <a:prstGeom prst="rect">
             <a:avLst/>
@@ -8501,14 +9188,635 @@
       </p:pic>
       <p:sp>
         <p:nvSpPr>
-          <p:cNvPr id="5" name="Rectangle 4"/>
+          <p:cNvPr id="6" name="Rectangle 5"/>
           <p:cNvSpPr/>
           <p:nvPr/>
         </p:nvSpPr>
         <p:spPr>
           <a:xfrm>
-            <a:off x="0" y="6217920"/>
-            <a:ext cx="12188952" cy="640080"/>
+            <a:off x="6903720" y="914400"/>
+            <a:ext cx="36576" cy="5669280"/>
+          </a:xfrm>
+          <a:prstGeom prst="rect">
+            <a:avLst/>
+          </a:prstGeom>
+          <a:solidFill>
+            <a:srgbClr val="4A4A7A"/>
+          </a:solidFill>
+          <a:ln>
+            <a:noFill/>
+          </a:ln>
+        </p:spPr>
+        <p:style>
+          <a:lnRef idx="1">
+            <a:schemeClr val="accent1"/>
+          </a:lnRef>
+          <a:fillRef idx="3">
+            <a:schemeClr val="accent1"/>
+          </a:fillRef>
+          <a:effectRef idx="2">
+            <a:schemeClr val="accent1"/>
+          </a:effectRef>
+          <a:fontRef idx="minor">
+            <a:schemeClr val="lt1"/>
+          </a:fontRef>
+        </p:style>
+        <p:txBody>
+          <a:bodyPr rtlCol="0" anchor="ctr"/>
+          <a:lstStyle/>
+          <a:p>
+            <a:pPr algn="ctr"/>
+          </a:p>
+        </p:txBody>
+      </p:sp>
+      <p:sp>
+        <p:nvSpPr>
+          <p:cNvPr id="7" name="Rectangle 6"/>
+          <p:cNvSpPr/>
+          <p:nvPr/>
+        </p:nvSpPr>
+        <p:spPr>
+          <a:xfrm>
+            <a:off x="6949440" y="914400"/>
+            <a:ext cx="5120640" cy="457200"/>
+          </a:xfrm>
+          <a:prstGeom prst="rect">
+            <a:avLst/>
+          </a:prstGeom>
+          <a:solidFill>
+            <a:srgbClr val="1E1E3E"/>
+          </a:solidFill>
+          <a:ln>
+            <a:noFill/>
+          </a:ln>
+        </p:spPr>
+        <p:style>
+          <a:lnRef idx="1">
+            <a:schemeClr val="accent1"/>
+          </a:lnRef>
+          <a:fillRef idx="3">
+            <a:schemeClr val="accent1"/>
+          </a:fillRef>
+          <a:effectRef idx="2">
+            <a:schemeClr val="accent1"/>
+          </a:effectRef>
+          <a:fontRef idx="minor">
+            <a:schemeClr val="lt1"/>
+          </a:fontRef>
+        </p:style>
+        <p:txBody>
+          <a:bodyPr rtlCol="0" anchor="ctr"/>
+          <a:lstStyle/>
+          <a:p>
+            <a:pPr algn="ctr"/>
+          </a:p>
+        </p:txBody>
+      </p:sp>
+      <p:sp>
+        <p:nvSpPr>
+          <p:cNvPr id="8" name="TextBox 7"/>
+          <p:cNvSpPr txBox="1"/>
+          <p:nvPr/>
+        </p:nvSpPr>
+        <p:spPr>
+          <a:xfrm>
+            <a:off x="7040880" y="960120"/>
+            <a:ext cx="4846320" cy="365760"/>
+          </a:xfrm>
+          <a:prstGeom prst="rect">
+            <a:avLst/>
+          </a:prstGeom>
+          <a:noFill/>
+        </p:spPr>
+        <p:txBody>
+          <a:bodyPr wrap="square">
+            <a:spAutoFit/>
+          </a:bodyPr>
+          <a:lstStyle/>
+          <a:p>
+            <a:r>
+              <a:rPr sz="1300" b="1" i="0">
+                <a:solidFill>
+                  <a:srgbClr val="4EFF9C"/>
+                </a:solidFill>
+              </a:rPr>
+              <a:t>🚀 咱们方案的升级点</a:t>
+            </a:r>
+          </a:p>
+        </p:txBody>
+      </p:sp>
+      <p:sp>
+        <p:nvSpPr>
+          <p:cNvPr id="9" name="Rectangle 8"/>
+          <p:cNvSpPr/>
+          <p:nvPr/>
+        </p:nvSpPr>
+        <p:spPr>
+          <a:xfrm>
+            <a:off x="6949440" y="1417320"/>
+            <a:ext cx="5120640" cy="411480"/>
+          </a:xfrm>
+          <a:prstGeom prst="rect">
+            <a:avLst/>
+          </a:prstGeom>
+          <a:solidFill>
+            <a:srgbClr val="222244"/>
+          </a:solidFill>
+          <a:ln>
+            <a:noFill/>
+          </a:ln>
+        </p:spPr>
+        <p:style>
+          <a:lnRef idx="1">
+            <a:schemeClr val="accent1"/>
+          </a:lnRef>
+          <a:fillRef idx="3">
+            <a:schemeClr val="accent1"/>
+          </a:fillRef>
+          <a:effectRef idx="2">
+            <a:schemeClr val="accent1"/>
+          </a:effectRef>
+          <a:fontRef idx="minor">
+            <a:schemeClr val="lt1"/>
+          </a:fontRef>
+        </p:style>
+        <p:txBody>
+          <a:bodyPr rtlCol="0" anchor="ctr"/>
+          <a:lstStyle/>
+          <a:p>
+            <a:pPr algn="ctr"/>
+          </a:p>
+        </p:txBody>
+      </p:sp>
+      <p:sp>
+        <p:nvSpPr>
+          <p:cNvPr id="10" name="TextBox 9"/>
+          <p:cNvSpPr txBox="1"/>
+          <p:nvPr/>
+        </p:nvSpPr>
+        <p:spPr>
+          <a:xfrm>
+            <a:off x="7040880" y="1463040"/>
+            <a:ext cx="4846320" cy="320040"/>
+          </a:xfrm>
+          <a:prstGeom prst="rect">
+            <a:avLst/>
+          </a:prstGeom>
+          <a:noFill/>
+        </p:spPr>
+        <p:txBody>
+          <a:bodyPr wrap="square">
+            <a:spAutoFit/>
+          </a:bodyPr>
+          <a:lstStyle/>
+          <a:p>
+            <a:r>
+              <a:rPr sz="1100" b="0" i="0">
+                <a:solidFill>
+                  <a:srgbClr val="AAAABB"/>
+                </a:solidFill>
+              </a:rPr>
+              <a:t>Clipper→Dataview→Graph→Marp</a:t>
+            </a:r>
+          </a:p>
+        </p:txBody>
+      </p:sp>
+      <p:sp>
+        <p:nvSpPr>
+          <p:cNvPr id="11" name="Rectangle 10"/>
+          <p:cNvSpPr/>
+          <p:nvPr/>
+        </p:nvSpPr>
+        <p:spPr>
+          <a:xfrm>
+            <a:off x="6949440" y="1920240"/>
+            <a:ext cx="5120640" cy="347472"/>
+          </a:xfrm>
+          <a:prstGeom prst="rect">
+            <a:avLst/>
+          </a:prstGeom>
+          <a:solidFill>
+            <a:srgbClr val="2A2A55"/>
+          </a:solidFill>
+          <a:ln>
+            <a:noFill/>
+          </a:ln>
+        </p:spPr>
+        <p:style>
+          <a:lnRef idx="1">
+            <a:schemeClr val="accent1"/>
+          </a:lnRef>
+          <a:fillRef idx="3">
+            <a:schemeClr val="accent1"/>
+          </a:fillRef>
+          <a:effectRef idx="2">
+            <a:schemeClr val="accent1"/>
+          </a:effectRef>
+          <a:fontRef idx="minor">
+            <a:schemeClr val="lt1"/>
+          </a:fontRef>
+        </p:style>
+        <p:txBody>
+          <a:bodyPr rtlCol="0" anchor="ctr"/>
+          <a:lstStyle/>
+          <a:p>
+            <a:pPr algn="ctr"/>
+          </a:p>
+        </p:txBody>
+      </p:sp>
+      <p:sp>
+        <p:nvSpPr>
+          <p:cNvPr id="12" name="TextBox 11"/>
+          <p:cNvSpPr txBox="1"/>
+          <p:nvPr/>
+        </p:nvSpPr>
+        <p:spPr>
+          <a:xfrm>
+            <a:off x="6995160" y="1938528"/>
+            <a:ext cx="5029200" cy="310896"/>
+          </a:xfrm>
+          <a:prstGeom prst="rect">
+            <a:avLst/>
+          </a:prstGeom>
+          <a:noFill/>
+        </p:spPr>
+        <p:txBody>
+          <a:bodyPr wrap="square">
+            <a:spAutoFit/>
+          </a:bodyPr>
+          <a:lstStyle/>
+          <a:p>
+            <a:r>
+              <a:rPr sz="1200" b="1" i="0">
+                <a:solidFill>
+                  <a:srgbClr val="6C5CF5"/>
+                </a:solidFill>
+              </a:rPr>
+              <a:t>  1. 自动化程度</a:t>
+            </a:r>
+          </a:p>
+        </p:txBody>
+      </p:sp>
+      <p:sp>
+        <p:nvSpPr>
+          <p:cNvPr id="13" name="TextBox 12"/>
+          <p:cNvSpPr txBox="1"/>
+          <p:nvPr/>
+        </p:nvSpPr>
+        <p:spPr>
+          <a:xfrm>
+            <a:off x="7040880" y="2286000"/>
+            <a:ext cx="5029200" cy="320040"/>
+          </a:xfrm>
+          <a:prstGeom prst="rect">
+            <a:avLst/>
+          </a:prstGeom>
+          <a:noFill/>
+        </p:spPr>
+        <p:txBody>
+          <a:bodyPr wrap="square">
+            <a:spAutoFit/>
+          </a:bodyPr>
+          <a:lstStyle/>
+          <a:p>
+            <a:r>
+              <a:rPr sz="1100" b="0" i="0">
+                <a:solidFill>
+                  <a:srgbClr val="E0E0FF"/>
+                </a:solidFill>
+              </a:rPr>
+              <a:t>    图里工具独立</a:t>
+            </a:r>
+          </a:p>
+        </p:txBody>
+      </p:sp>
+      <p:sp>
+        <p:nvSpPr>
+          <p:cNvPr id="14" name="TextBox 13"/>
+          <p:cNvSpPr txBox="1"/>
+          <p:nvPr/>
+        </p:nvSpPr>
+        <p:spPr>
+          <a:xfrm>
+            <a:off x="7040880" y="2633472"/>
+            <a:ext cx="5029200" cy="320040"/>
+          </a:xfrm>
+          <a:prstGeom prst="rect">
+            <a:avLst/>
+          </a:prstGeom>
+          <a:noFill/>
+        </p:spPr>
+        <p:txBody>
+          <a:bodyPr wrap="square">
+            <a:spAutoFit/>
+          </a:bodyPr>
+          <a:lstStyle/>
+          <a:p>
+            <a:r>
+              <a:rPr sz="1100" b="0" i="0">
+                <a:solidFill>
+                  <a:srgbClr val="E0E0FF"/>
+                </a:solidFill>
+              </a:rPr>
+              <a:t>    咱们 watcher 监控 + Cron 自动触发</a:t>
+            </a:r>
+          </a:p>
+        </p:txBody>
+      </p:sp>
+      <p:sp>
+        <p:nvSpPr>
+          <p:cNvPr id="15" name="Rectangle 14"/>
+          <p:cNvSpPr/>
+          <p:nvPr/>
+        </p:nvSpPr>
+        <p:spPr>
+          <a:xfrm>
+            <a:off x="6949440" y="3072384"/>
+            <a:ext cx="5120640" cy="347472"/>
+          </a:xfrm>
+          <a:prstGeom prst="rect">
+            <a:avLst/>
+          </a:prstGeom>
+          <a:solidFill>
+            <a:srgbClr val="2A2A55"/>
+          </a:solidFill>
+          <a:ln>
+            <a:noFill/>
+          </a:ln>
+        </p:spPr>
+        <p:style>
+          <a:lnRef idx="1">
+            <a:schemeClr val="accent1"/>
+          </a:lnRef>
+          <a:fillRef idx="3">
+            <a:schemeClr val="accent1"/>
+          </a:fillRef>
+          <a:effectRef idx="2">
+            <a:schemeClr val="accent1"/>
+          </a:effectRef>
+          <a:fontRef idx="minor">
+            <a:schemeClr val="lt1"/>
+          </a:fontRef>
+        </p:style>
+        <p:txBody>
+          <a:bodyPr rtlCol="0" anchor="ctr"/>
+          <a:lstStyle/>
+          <a:p>
+            <a:pPr algn="ctr"/>
+          </a:p>
+        </p:txBody>
+      </p:sp>
+      <p:sp>
+        <p:nvSpPr>
+          <p:cNvPr id="16" name="TextBox 15"/>
+          <p:cNvSpPr txBox="1"/>
+          <p:nvPr/>
+        </p:nvSpPr>
+        <p:spPr>
+          <a:xfrm>
+            <a:off x="6995160" y="3090672"/>
+            <a:ext cx="5029200" cy="310896"/>
+          </a:xfrm>
+          <a:prstGeom prst="rect">
+            <a:avLst/>
+          </a:prstGeom>
+          <a:noFill/>
+        </p:spPr>
+        <p:txBody>
+          <a:bodyPr wrap="square">
+            <a:spAutoFit/>
+          </a:bodyPr>
+          <a:lstStyle/>
+          <a:p>
+            <a:r>
+              <a:rPr sz="1200" b="1" i="0">
+                <a:solidFill>
+                  <a:srgbClr val="6C5CF5"/>
+                </a:solidFill>
+              </a:rPr>
+              <a:t>  2. Query 体验</a:t>
+            </a:r>
+          </a:p>
+        </p:txBody>
+      </p:sp>
+      <p:sp>
+        <p:nvSpPr>
+          <p:cNvPr id="17" name="TextBox 16"/>
+          <p:cNvSpPr txBox="1"/>
+          <p:nvPr/>
+        </p:nvSpPr>
+        <p:spPr>
+          <a:xfrm>
+            <a:off x="7040880" y="3438144"/>
+            <a:ext cx="5029200" cy="320040"/>
+          </a:xfrm>
+          <a:prstGeom prst="rect">
+            <a:avLst/>
+          </a:prstGeom>
+          <a:noFill/>
+        </p:spPr>
+        <p:txBody>
+          <a:bodyPr wrap="square">
+            <a:spAutoFit/>
+          </a:bodyPr>
+          <a:lstStyle/>
+          <a:p>
+            <a:r>
+              <a:rPr sz="1100" b="0" i="0">
+                <a:solidFill>
+                  <a:srgbClr val="E0E0FF"/>
+                </a:solidFill>
+              </a:rPr>
+              <a:t>    图里用 Dataview</a:t>
+            </a:r>
+          </a:p>
+        </p:txBody>
+      </p:sp>
+      <p:sp>
+        <p:nvSpPr>
+          <p:cNvPr id="18" name="TextBox 17"/>
+          <p:cNvSpPr txBox="1"/>
+          <p:nvPr/>
+        </p:nvSpPr>
+        <p:spPr>
+          <a:xfrm>
+            <a:off x="7040880" y="3785615"/>
+            <a:ext cx="5029200" cy="320040"/>
+          </a:xfrm>
+          <a:prstGeom prst="rect">
+            <a:avLst/>
+          </a:prstGeom>
+          <a:noFill/>
+        </p:spPr>
+        <p:txBody>
+          <a:bodyPr wrap="square">
+            <a:spAutoFit/>
+          </a:bodyPr>
+          <a:lstStyle/>
+          <a:p>
+            <a:r>
+              <a:rPr sz="1100" b="0" i="0">
+                <a:solidFill>
+                  <a:srgbClr val="E0E0FF"/>
+                </a:solidFill>
+              </a:rPr>
+              <a:t>    咱们用 QMD 语义搜索（更智能）</a:t>
+            </a:r>
+          </a:p>
+        </p:txBody>
+      </p:sp>
+      <p:sp>
+        <p:nvSpPr>
+          <p:cNvPr id="19" name="Rectangle 18"/>
+          <p:cNvSpPr/>
+          <p:nvPr/>
+        </p:nvSpPr>
+        <p:spPr>
+          <a:xfrm>
+            <a:off x="6949440" y="4224527"/>
+            <a:ext cx="5120640" cy="347472"/>
+          </a:xfrm>
+          <a:prstGeom prst="rect">
+            <a:avLst/>
+          </a:prstGeom>
+          <a:solidFill>
+            <a:srgbClr val="2A2A55"/>
+          </a:solidFill>
+          <a:ln>
+            <a:noFill/>
+          </a:ln>
+        </p:spPr>
+        <p:style>
+          <a:lnRef idx="1">
+            <a:schemeClr val="accent1"/>
+          </a:lnRef>
+          <a:fillRef idx="3">
+            <a:schemeClr val="accent1"/>
+          </a:fillRef>
+          <a:effectRef idx="2">
+            <a:schemeClr val="accent1"/>
+          </a:effectRef>
+          <a:fontRef idx="minor">
+            <a:schemeClr val="lt1"/>
+          </a:fontRef>
+        </p:style>
+        <p:txBody>
+          <a:bodyPr rtlCol="0" anchor="ctr"/>
+          <a:lstStyle/>
+          <a:p>
+            <a:pPr algn="ctr"/>
+          </a:p>
+        </p:txBody>
+      </p:sp>
+      <p:sp>
+        <p:nvSpPr>
+          <p:cNvPr id="20" name="TextBox 19"/>
+          <p:cNvSpPr txBox="1"/>
+          <p:nvPr/>
+        </p:nvSpPr>
+        <p:spPr>
+          <a:xfrm>
+            <a:off x="6995160" y="4242815"/>
+            <a:ext cx="5029200" cy="310896"/>
+          </a:xfrm>
+          <a:prstGeom prst="rect">
+            <a:avLst/>
+          </a:prstGeom>
+          <a:noFill/>
+        </p:spPr>
+        <p:txBody>
+          <a:bodyPr wrap="square">
+            <a:spAutoFit/>
+          </a:bodyPr>
+          <a:lstStyle/>
+          <a:p>
+            <a:r>
+              <a:rPr sz="1200" b="1" i="0">
+                <a:solidFill>
+                  <a:srgbClr val="6C5CF5"/>
+                </a:solidFill>
+              </a:rPr>
+              <a:t>  3. Output</a:t>
+            </a:r>
+          </a:p>
+        </p:txBody>
+      </p:sp>
+      <p:sp>
+        <p:nvSpPr>
+          <p:cNvPr id="21" name="TextBox 20"/>
+          <p:cNvSpPr txBox="1"/>
+          <p:nvPr/>
+        </p:nvSpPr>
+        <p:spPr>
+          <a:xfrm>
+            <a:off x="7040880" y="4590288"/>
+            <a:ext cx="5029200" cy="320040"/>
+          </a:xfrm>
+          <a:prstGeom prst="rect">
+            <a:avLst/>
+          </a:prstGeom>
+          <a:noFill/>
+        </p:spPr>
+        <p:txBody>
+          <a:bodyPr wrap="square">
+            <a:spAutoFit/>
+          </a:bodyPr>
+          <a:lstStyle/>
+          <a:p>
+            <a:r>
+              <a:rPr sz="1100" b="0" i="0">
+                <a:solidFill>
+                  <a:srgbClr val="E0E0FF"/>
+                </a:solidFill>
+              </a:rPr>
+              <a:t>    图里用 Marp</a:t>
+            </a:r>
+          </a:p>
+        </p:txBody>
+      </p:sp>
+      <p:sp>
+        <p:nvSpPr>
+          <p:cNvPr id="22" name="TextBox 21"/>
+          <p:cNvSpPr txBox="1"/>
+          <p:nvPr/>
+        </p:nvSpPr>
+        <p:spPr>
+          <a:xfrm>
+            <a:off x="7040880" y="4937759"/>
+            <a:ext cx="5029200" cy="320040"/>
+          </a:xfrm>
+          <a:prstGeom prst="rect">
+            <a:avLst/>
+          </a:prstGeom>
+          <a:noFill/>
+        </p:spPr>
+        <p:txBody>
+          <a:bodyPr wrap="square">
+            <a:spAutoFit/>
+          </a:bodyPr>
+          <a:lstStyle/>
+          <a:p>
+            <a:r>
+              <a:rPr sz="1100" b="0" i="0">
+                <a:solidFill>
+                  <a:srgbClr val="E0E0FF"/>
+                </a:solidFill>
+              </a:rPr>
+              <a:t>    咱们 python-pptx 自动生成</a:t>
+            </a:r>
+          </a:p>
+        </p:txBody>
+      </p:sp>
+      <p:sp>
+        <p:nvSpPr>
+          <p:cNvPr id="23" name="Rectangle 22"/>
+          <p:cNvSpPr/>
+          <p:nvPr/>
+        </p:nvSpPr>
+        <p:spPr>
+          <a:xfrm>
+            <a:off x="0" y="6583680"/>
+            <a:ext cx="12188952" cy="274320"/>
           </a:xfrm>
           <a:prstGeom prst="rect">
             <a:avLst/>
@@ -8544,33 +9852,33 @@
       </p:sp>
       <p:sp>
         <p:nvSpPr>
-          <p:cNvPr id="6" name="TextBox 5"/>
-          <p:cNvSpPr txBox="1"/>
-          <p:nvPr/>
-        </p:nvSpPr>
-        <p:spPr>
-          <a:xfrm>
-            <a:off x="457200" y="6263640"/>
-            <a:ext cx="10972800" cy="457200"/>
-          </a:xfrm>
-          <a:prstGeom prst="rect">
-            <a:avLst/>
-          </a:prstGeom>
-          <a:noFill/>
-        </p:spPr>
-        <p:txBody>
-          <a:bodyPr wrap="none">
-            <a:spAutoFit/>
-          </a:bodyPr>
-          <a:lstStyle/>
-          <a:p>
-            <a:r>
-              <a:rPr sz="1400">
+          <p:cNvPr id="24" name="TextBox 23"/>
+          <p:cNvSpPr txBox="1"/>
+          <p:nvPr/>
+        </p:nvSpPr>
+        <p:spPr>
+          <a:xfrm>
+            <a:off x="365760" y="6601968"/>
+            <a:ext cx="10972800" cy="228600"/>
+          </a:xfrm>
+          <a:prstGeom prst="rect">
+            <a:avLst/>
+          </a:prstGeom>
+          <a:noFill/>
+        </p:spPr>
+        <p:txBody>
+          <a:bodyPr wrap="square">
+            <a:spAutoFit/>
+          </a:bodyPr>
+          <a:lstStyle/>
+          <a:p>
+            <a:r>
+              <a:rPr sz="1000" b="0" i="0">
                 <a:solidFill>
                   <a:srgbClr val="AAAABB"/>
                 </a:solidFill>
               </a:rPr>
-              <a:t>Clipper → Dataview → Graph View → Marp</a:t>
+              <a:t>来源：Aki聊AI  |  对比：咱们方案</a:t>
             </a:r>
           </a:p>
         </p:txBody>
@@ -8610,7 +9918,7 @@
         <p:spPr>
           <a:xfrm>
             <a:off x="0" y="0"/>
-            <a:ext cx="12188952" cy="1005840"/>
+            <a:ext cx="12188952" cy="822960"/>
           </a:xfrm>
           <a:prstGeom prst="rect">
             <a:avLst/>
@@ -8652,34 +9960,67 @@
         </p:nvSpPr>
         <p:spPr>
           <a:xfrm>
-            <a:off x="457200" y="137160"/>
-            <a:ext cx="10972800" cy="731520"/>
-          </a:xfrm>
-          <a:prstGeom prst="rect">
-            <a:avLst/>
-          </a:prstGeom>
-          <a:noFill/>
-        </p:spPr>
-        <p:txBody>
-          <a:bodyPr wrap="none">
-            <a:spAutoFit/>
-          </a:bodyPr>
-          <a:lstStyle/>
-          <a:p>
-            <a:r>
-              <a:rPr sz="2600" b="1">
+            <a:off x="365760" y="91440"/>
+            <a:ext cx="7315200" cy="640080"/>
+          </a:xfrm>
+          <a:prstGeom prst="rect">
+            <a:avLst/>
+          </a:prstGeom>
+          <a:noFill/>
+        </p:spPr>
+        <p:txBody>
+          <a:bodyPr wrap="square">
+            <a:spAutoFit/>
+          </a:bodyPr>
+          <a:lstStyle/>
+          <a:p>
+            <a:r>
+              <a:rPr sz="2200" b="1" i="0">
                 <a:solidFill>
                   <a:srgbClr val="6C5CF5"/>
                 </a:solidFill>
               </a:rPr>
               <a:t>📊 AI 第二大脑的价值</a:t>
+            </a:r>
+          </a:p>
+        </p:txBody>
+      </p:sp>
+      <p:sp>
+        <p:nvSpPr>
+          <p:cNvPr id="4" name="TextBox 3"/>
+          <p:cNvSpPr txBox="1"/>
+          <p:nvPr/>
+        </p:nvSpPr>
+        <p:spPr>
+          <a:xfrm>
+            <a:off x="7772400" y="137160"/>
+            <a:ext cx="4114800" cy="548640"/>
+          </a:xfrm>
+          <a:prstGeom prst="rect">
+            <a:avLst/>
+          </a:prstGeom>
+          <a:noFill/>
+        </p:spPr>
+        <p:txBody>
+          <a:bodyPr wrap="square">
+            <a:spAutoFit/>
+          </a:bodyPr>
+          <a:lstStyle/>
+          <a:p>
+            <a:r>
+              <a:rPr sz="1300" b="0" i="0">
+                <a:solidFill>
+                  <a:srgbClr val="AAAABB"/>
+                </a:solidFill>
+              </a:rPr>
+              <a:t>图里方案 vs 咱们方案</a:t>
             </a:r>
           </a:p>
         </p:txBody>
       </p:sp>
       <p:pic>
         <p:nvPicPr>
-          <p:cNvPr id="4" name="Picture 3" descr="知识库参考图_3_AI第二大脑价值.jpg"/>
+          <p:cNvPr id="5" name="Picture 4" descr="知识库参考图_3_AI第二大脑价值.jpg"/>
           <p:cNvPicPr>
             <a:picLocks noChangeAspect="1"/>
           </p:cNvPicPr>
@@ -8693,8 +10034,8 @@
         </p:blipFill>
         <p:spPr>
           <a:xfrm>
-            <a:off x="274320" y="1188720"/>
-            <a:ext cx="11612880" cy="4846320"/>
+            <a:off x="182880" y="914400"/>
+            <a:ext cx="6583680" cy="5669280"/>
           </a:xfrm>
           <a:prstGeom prst="rect">
             <a:avLst/>
@@ -8703,14 +10044,602 @@
       </p:pic>
       <p:sp>
         <p:nvSpPr>
-          <p:cNvPr id="5" name="Rectangle 4"/>
+          <p:cNvPr id="6" name="Rectangle 5"/>
           <p:cNvSpPr/>
           <p:nvPr/>
         </p:nvSpPr>
         <p:spPr>
           <a:xfrm>
-            <a:off x="0" y="6217920"/>
-            <a:ext cx="12188952" cy="640080"/>
+            <a:off x="6903720" y="914400"/>
+            <a:ext cx="36576" cy="5669280"/>
+          </a:xfrm>
+          <a:prstGeom prst="rect">
+            <a:avLst/>
+          </a:prstGeom>
+          <a:solidFill>
+            <a:srgbClr val="4A4A7A"/>
+          </a:solidFill>
+          <a:ln>
+            <a:noFill/>
+          </a:ln>
+        </p:spPr>
+        <p:style>
+          <a:lnRef idx="1">
+            <a:schemeClr val="accent1"/>
+          </a:lnRef>
+          <a:fillRef idx="3">
+            <a:schemeClr val="accent1"/>
+          </a:fillRef>
+          <a:effectRef idx="2">
+            <a:schemeClr val="accent1"/>
+          </a:effectRef>
+          <a:fontRef idx="minor">
+            <a:schemeClr val="lt1"/>
+          </a:fontRef>
+        </p:style>
+        <p:txBody>
+          <a:bodyPr rtlCol="0" anchor="ctr"/>
+          <a:lstStyle/>
+          <a:p>
+            <a:pPr algn="ctr"/>
+          </a:p>
+        </p:txBody>
+      </p:sp>
+      <p:sp>
+        <p:nvSpPr>
+          <p:cNvPr id="7" name="Rectangle 6"/>
+          <p:cNvSpPr/>
+          <p:nvPr/>
+        </p:nvSpPr>
+        <p:spPr>
+          <a:xfrm>
+            <a:off x="6949440" y="914400"/>
+            <a:ext cx="5120640" cy="457200"/>
+          </a:xfrm>
+          <a:prstGeom prst="rect">
+            <a:avLst/>
+          </a:prstGeom>
+          <a:solidFill>
+            <a:srgbClr val="1E1E3E"/>
+          </a:solidFill>
+          <a:ln>
+            <a:noFill/>
+          </a:ln>
+        </p:spPr>
+        <p:style>
+          <a:lnRef idx="1">
+            <a:schemeClr val="accent1"/>
+          </a:lnRef>
+          <a:fillRef idx="3">
+            <a:schemeClr val="accent1"/>
+          </a:fillRef>
+          <a:effectRef idx="2">
+            <a:schemeClr val="accent1"/>
+          </a:effectRef>
+          <a:fontRef idx="minor">
+            <a:schemeClr val="lt1"/>
+          </a:fontRef>
+        </p:style>
+        <p:txBody>
+          <a:bodyPr rtlCol="0" anchor="ctr"/>
+          <a:lstStyle/>
+          <a:p>
+            <a:pPr algn="ctr"/>
+          </a:p>
+        </p:txBody>
+      </p:sp>
+      <p:sp>
+        <p:nvSpPr>
+          <p:cNvPr id="8" name="TextBox 7"/>
+          <p:cNvSpPr txBox="1"/>
+          <p:nvPr/>
+        </p:nvSpPr>
+        <p:spPr>
+          <a:xfrm>
+            <a:off x="7040880" y="960120"/>
+            <a:ext cx="4846320" cy="365760"/>
+          </a:xfrm>
+          <a:prstGeom prst="rect">
+            <a:avLst/>
+          </a:prstGeom>
+          <a:noFill/>
+        </p:spPr>
+        <p:txBody>
+          <a:bodyPr wrap="square">
+            <a:spAutoFit/>
+          </a:bodyPr>
+          <a:lstStyle/>
+          <a:p>
+            <a:r>
+              <a:rPr sz="1300" b="1" i="0">
+                <a:solidFill>
+                  <a:srgbClr val="4EFF9C"/>
+                </a:solidFill>
+              </a:rPr>
+              <a:t>🚀 咱们方案的升级点</a:t>
+            </a:r>
+          </a:p>
+        </p:txBody>
+      </p:sp>
+      <p:sp>
+        <p:nvSpPr>
+          <p:cNvPr id="9" name="Rectangle 8"/>
+          <p:cNvSpPr/>
+          <p:nvPr/>
+        </p:nvSpPr>
+        <p:spPr>
+          <a:xfrm>
+            <a:off x="6949440" y="1417320"/>
+            <a:ext cx="5120640" cy="411480"/>
+          </a:xfrm>
+          <a:prstGeom prst="rect">
+            <a:avLst/>
+          </a:prstGeom>
+          <a:solidFill>
+            <a:srgbClr val="222244"/>
+          </a:solidFill>
+          <a:ln>
+            <a:noFill/>
+          </a:ln>
+        </p:spPr>
+        <p:style>
+          <a:lnRef idx="1">
+            <a:schemeClr val="accent1"/>
+          </a:lnRef>
+          <a:fillRef idx="3">
+            <a:schemeClr val="accent1"/>
+          </a:fillRef>
+          <a:effectRef idx="2">
+            <a:schemeClr val="accent1"/>
+          </a:effectRef>
+          <a:fontRef idx="minor">
+            <a:schemeClr val="lt1"/>
+          </a:fontRef>
+        </p:style>
+        <p:txBody>
+          <a:bodyPr rtlCol="0" anchor="ctr"/>
+          <a:lstStyle/>
+          <a:p>
+            <a:pPr algn="ctr"/>
+          </a:p>
+        </p:txBody>
+      </p:sp>
+      <p:sp>
+        <p:nvSpPr>
+          <p:cNvPr id="10" name="TextBox 9"/>
+          <p:cNvSpPr txBox="1"/>
+          <p:nvPr/>
+        </p:nvSpPr>
+        <p:spPr>
+          <a:xfrm>
+            <a:off x="7040880" y="1463040"/>
+            <a:ext cx="4846320" cy="320040"/>
+          </a:xfrm>
+          <a:prstGeom prst="rect">
+            <a:avLst/>
+          </a:prstGeom>
+          <a:noFill/>
+        </p:spPr>
+        <p:txBody>
+          <a:bodyPr wrap="square">
+            <a:spAutoFit/>
+          </a:bodyPr>
+          <a:lstStyle/>
+          <a:p>
+            <a:r>
+              <a:rPr sz="1100" b="0" i="0">
+                <a:solidFill>
+                  <a:srgbClr val="AAAABB"/>
+                </a:solidFill>
+              </a:rPr>
+              <a:t>统一沉淀 / 检索复用 / 增值资产</a:t>
+            </a:r>
+          </a:p>
+        </p:txBody>
+      </p:sp>
+      <p:sp>
+        <p:nvSpPr>
+          <p:cNvPr id="11" name="Rectangle 10"/>
+          <p:cNvSpPr/>
+          <p:nvPr/>
+        </p:nvSpPr>
+        <p:spPr>
+          <a:xfrm>
+            <a:off x="6949440" y="1920240"/>
+            <a:ext cx="5120640" cy="347472"/>
+          </a:xfrm>
+          <a:prstGeom prst="rect">
+            <a:avLst/>
+          </a:prstGeom>
+          <a:solidFill>
+            <a:srgbClr val="2A2A55"/>
+          </a:solidFill>
+          <a:ln>
+            <a:noFill/>
+          </a:ln>
+        </p:spPr>
+        <p:style>
+          <a:lnRef idx="1">
+            <a:schemeClr val="accent1"/>
+          </a:lnRef>
+          <a:fillRef idx="3">
+            <a:schemeClr val="accent1"/>
+          </a:fillRef>
+          <a:effectRef idx="2">
+            <a:schemeClr val="accent1"/>
+          </a:effectRef>
+          <a:fontRef idx="minor">
+            <a:schemeClr val="lt1"/>
+          </a:fontRef>
+        </p:style>
+        <p:txBody>
+          <a:bodyPr rtlCol="0" anchor="ctr"/>
+          <a:lstStyle/>
+          <a:p>
+            <a:pPr algn="ctr"/>
+          </a:p>
+        </p:txBody>
+      </p:sp>
+      <p:sp>
+        <p:nvSpPr>
+          <p:cNvPr id="12" name="TextBox 11"/>
+          <p:cNvSpPr txBox="1"/>
+          <p:nvPr/>
+        </p:nvSpPr>
+        <p:spPr>
+          <a:xfrm>
+            <a:off x="6995160" y="1938528"/>
+            <a:ext cx="5029200" cy="310896"/>
+          </a:xfrm>
+          <a:prstGeom prst="rect">
+            <a:avLst/>
+          </a:prstGeom>
+          <a:noFill/>
+        </p:spPr>
+        <p:txBody>
+          <a:bodyPr wrap="square">
+            <a:spAutoFit/>
+          </a:bodyPr>
+          <a:lstStyle/>
+          <a:p>
+            <a:r>
+              <a:rPr sz="1200" b="1" i="0">
+                <a:solidFill>
+                  <a:srgbClr val="6C5CF5"/>
+                </a:solidFill>
+              </a:rPr>
+              <a:t>  1. 统一沉淀</a:t>
+            </a:r>
+          </a:p>
+        </p:txBody>
+      </p:sp>
+      <p:sp>
+        <p:nvSpPr>
+          <p:cNvPr id="13" name="TextBox 12"/>
+          <p:cNvSpPr txBox="1"/>
+          <p:nvPr/>
+        </p:nvSpPr>
+        <p:spPr>
+          <a:xfrm>
+            <a:off x="7040880" y="2286000"/>
+            <a:ext cx="5029200" cy="320040"/>
+          </a:xfrm>
+          <a:prstGeom prst="rect">
+            <a:avLst/>
+          </a:prstGeom>
+          <a:noFill/>
+        </p:spPr>
+        <p:txBody>
+          <a:bodyPr wrap="square">
+            <a:spAutoFit/>
+          </a:bodyPr>
+          <a:lstStyle/>
+          <a:p>
+            <a:r>
+              <a:rPr sz="1100" b="0" i="0">
+                <a:solidFill>
+                  <a:srgbClr val="E0E0FF"/>
+                </a:solidFill>
+              </a:rPr>
+              <a:t>    图里手动分类</a:t>
+            </a:r>
+          </a:p>
+        </p:txBody>
+      </p:sp>
+      <p:sp>
+        <p:nvSpPr>
+          <p:cNvPr id="14" name="TextBox 13"/>
+          <p:cNvSpPr txBox="1"/>
+          <p:nvPr/>
+        </p:nvSpPr>
+        <p:spPr>
+          <a:xfrm>
+            <a:off x="7040880" y="2633472"/>
+            <a:ext cx="5029200" cy="320040"/>
+          </a:xfrm>
+          <a:prstGeom prst="rect">
+            <a:avLst/>
+          </a:prstGeom>
+          <a:noFill/>
+        </p:spPr>
+        <p:txBody>
+          <a:bodyPr wrap="square">
+            <a:spAutoFit/>
+          </a:bodyPr>
+          <a:lstStyle/>
+          <a:p>
+            <a:r>
+              <a:rPr sz="1100" b="0" i="0">
+                <a:solidFill>
+                  <a:srgbClr val="E0E0FF"/>
+                </a:solidFill>
+              </a:rPr>
+              <a:t>    咱们 auto_ingest 自动分类到 articles/papers/notes</a:t>
+            </a:r>
+          </a:p>
+        </p:txBody>
+      </p:sp>
+      <p:sp>
+        <p:nvSpPr>
+          <p:cNvPr id="15" name="Rectangle 14"/>
+          <p:cNvSpPr/>
+          <p:nvPr/>
+        </p:nvSpPr>
+        <p:spPr>
+          <a:xfrm>
+            <a:off x="6949440" y="3072384"/>
+            <a:ext cx="5120640" cy="347472"/>
+          </a:xfrm>
+          <a:prstGeom prst="rect">
+            <a:avLst/>
+          </a:prstGeom>
+          <a:solidFill>
+            <a:srgbClr val="2A2A55"/>
+          </a:solidFill>
+          <a:ln>
+            <a:noFill/>
+          </a:ln>
+        </p:spPr>
+        <p:style>
+          <a:lnRef idx="1">
+            <a:schemeClr val="accent1"/>
+          </a:lnRef>
+          <a:fillRef idx="3">
+            <a:schemeClr val="accent1"/>
+          </a:fillRef>
+          <a:effectRef idx="2">
+            <a:schemeClr val="accent1"/>
+          </a:effectRef>
+          <a:fontRef idx="minor">
+            <a:schemeClr val="lt1"/>
+          </a:fontRef>
+        </p:style>
+        <p:txBody>
+          <a:bodyPr rtlCol="0" anchor="ctr"/>
+          <a:lstStyle/>
+          <a:p>
+            <a:pPr algn="ctr"/>
+          </a:p>
+        </p:txBody>
+      </p:sp>
+      <p:sp>
+        <p:nvSpPr>
+          <p:cNvPr id="16" name="TextBox 15"/>
+          <p:cNvSpPr txBox="1"/>
+          <p:nvPr/>
+        </p:nvSpPr>
+        <p:spPr>
+          <a:xfrm>
+            <a:off x="6995160" y="3090672"/>
+            <a:ext cx="5029200" cy="310896"/>
+          </a:xfrm>
+          <a:prstGeom prst="rect">
+            <a:avLst/>
+          </a:prstGeom>
+          <a:noFill/>
+        </p:spPr>
+        <p:txBody>
+          <a:bodyPr wrap="square">
+            <a:spAutoFit/>
+          </a:bodyPr>
+          <a:lstStyle/>
+          <a:p>
+            <a:r>
+              <a:rPr sz="1200" b="1" i="0">
+                <a:solidFill>
+                  <a:srgbClr val="6C5CF5"/>
+                </a:solidFill>
+              </a:rPr>
+              <a:t>  2. 检索复用</a:t>
+            </a:r>
+          </a:p>
+        </p:txBody>
+      </p:sp>
+      <p:sp>
+        <p:nvSpPr>
+          <p:cNvPr id="17" name="TextBox 16"/>
+          <p:cNvSpPr txBox="1"/>
+          <p:nvPr/>
+        </p:nvSpPr>
+        <p:spPr>
+          <a:xfrm>
+            <a:off x="7040880" y="3438144"/>
+            <a:ext cx="5029200" cy="320040"/>
+          </a:xfrm>
+          <a:prstGeom prst="rect">
+            <a:avLst/>
+          </a:prstGeom>
+          <a:noFill/>
+        </p:spPr>
+        <p:txBody>
+          <a:bodyPr wrap="square">
+            <a:spAutoFit/>
+          </a:bodyPr>
+          <a:lstStyle/>
+          <a:p>
+            <a:r>
+              <a:rPr sz="1100" b="0" i="0">
+                <a:solidFill>
+                  <a:srgbClr val="E0E0FF"/>
+                </a:solidFill>
+              </a:rPr>
+              <a:t>    图里靠 Dataview 查询</a:t>
+            </a:r>
+          </a:p>
+        </p:txBody>
+      </p:sp>
+      <p:sp>
+        <p:nvSpPr>
+          <p:cNvPr id="18" name="TextBox 17"/>
+          <p:cNvSpPr txBox="1"/>
+          <p:nvPr/>
+        </p:nvSpPr>
+        <p:spPr>
+          <a:xfrm>
+            <a:off x="7040880" y="3785615"/>
+            <a:ext cx="5029200" cy="320040"/>
+          </a:xfrm>
+          <a:prstGeom prst="rect">
+            <a:avLst/>
+          </a:prstGeom>
+          <a:noFill/>
+        </p:spPr>
+        <p:txBody>
+          <a:bodyPr wrap="square">
+            <a:spAutoFit/>
+          </a:bodyPr>
+          <a:lstStyle/>
+          <a:p>
+            <a:r>
+              <a:rPr sz="1100" b="0" i="0">
+                <a:solidFill>
+                  <a:srgbClr val="E0E0FF"/>
+                </a:solidFill>
+              </a:rPr>
+              <a:t>    咱们 QMD 语义搜索 + Dataview 双轨</a:t>
+            </a:r>
+          </a:p>
+        </p:txBody>
+      </p:sp>
+      <p:sp>
+        <p:nvSpPr>
+          <p:cNvPr id="19" name="Rectangle 18"/>
+          <p:cNvSpPr/>
+          <p:nvPr/>
+        </p:nvSpPr>
+        <p:spPr>
+          <a:xfrm>
+            <a:off x="6949440" y="4224527"/>
+            <a:ext cx="5120640" cy="347472"/>
+          </a:xfrm>
+          <a:prstGeom prst="rect">
+            <a:avLst/>
+          </a:prstGeom>
+          <a:solidFill>
+            <a:srgbClr val="2A2A55"/>
+          </a:solidFill>
+          <a:ln>
+            <a:noFill/>
+          </a:ln>
+        </p:spPr>
+        <p:style>
+          <a:lnRef idx="1">
+            <a:schemeClr val="accent1"/>
+          </a:lnRef>
+          <a:fillRef idx="3">
+            <a:schemeClr val="accent1"/>
+          </a:fillRef>
+          <a:effectRef idx="2">
+            <a:schemeClr val="accent1"/>
+          </a:effectRef>
+          <a:fontRef idx="minor">
+            <a:schemeClr val="lt1"/>
+          </a:fontRef>
+        </p:style>
+        <p:txBody>
+          <a:bodyPr rtlCol="0" anchor="ctr"/>
+          <a:lstStyle/>
+          <a:p>
+            <a:pPr algn="ctr"/>
+          </a:p>
+        </p:txBody>
+      </p:sp>
+      <p:sp>
+        <p:nvSpPr>
+          <p:cNvPr id="20" name="TextBox 19"/>
+          <p:cNvSpPr txBox="1"/>
+          <p:nvPr/>
+        </p:nvSpPr>
+        <p:spPr>
+          <a:xfrm>
+            <a:off x="6995160" y="4242815"/>
+            <a:ext cx="5029200" cy="310896"/>
+          </a:xfrm>
+          <a:prstGeom prst="rect">
+            <a:avLst/>
+          </a:prstGeom>
+          <a:noFill/>
+        </p:spPr>
+        <p:txBody>
+          <a:bodyPr wrap="square">
+            <a:spAutoFit/>
+          </a:bodyPr>
+          <a:lstStyle/>
+          <a:p>
+            <a:r>
+              <a:rPr sz="1200" b="1" i="0">
+                <a:solidFill>
+                  <a:srgbClr val="6C5CF5"/>
+                </a:solidFill>
+              </a:rPr>
+              <a:t>  3. 数字资产</a:t>
+            </a:r>
+          </a:p>
+        </p:txBody>
+      </p:sp>
+      <p:sp>
+        <p:nvSpPr>
+          <p:cNvPr id="21" name="TextBox 20"/>
+          <p:cNvSpPr txBox="1"/>
+          <p:nvPr/>
+        </p:nvSpPr>
+        <p:spPr>
+          <a:xfrm>
+            <a:off x="7040880" y="4590288"/>
+            <a:ext cx="5029200" cy="320040"/>
+          </a:xfrm>
+          <a:prstGeom prst="rect">
+            <a:avLst/>
+          </a:prstGeom>
+          <a:noFill/>
+        </p:spPr>
+        <p:txBody>
+          <a:bodyPr wrap="square">
+            <a:spAutoFit/>
+          </a:bodyPr>
+          <a:lstStyle/>
+          <a:p>
+            <a:r>
+              <a:rPr sz="1100" b="0" i="0">
+                <a:solidFill>
+                  <a:srgbClr val="E0E0FF"/>
+                </a:solidFill>
+              </a:rPr>
+              <a:t>    咱们输出成果：wiki-graph.html、D3图谱、PPT</a:t>
+            </a:r>
+          </a:p>
+        </p:txBody>
+      </p:sp>
+      <p:sp>
+        <p:nvSpPr>
+          <p:cNvPr id="22" name="Rectangle 21"/>
+          <p:cNvSpPr/>
+          <p:nvPr/>
+        </p:nvSpPr>
+        <p:spPr>
+          <a:xfrm>
+            <a:off x="0" y="6583680"/>
+            <a:ext cx="12188952" cy="274320"/>
           </a:xfrm>
           <a:prstGeom prst="rect">
             <a:avLst/>
@@ -8746,33 +10675,33 @@
       </p:sp>
       <p:sp>
         <p:nvSpPr>
-          <p:cNvPr id="6" name="TextBox 5"/>
-          <p:cNvSpPr txBox="1"/>
-          <p:nvPr/>
-        </p:nvSpPr>
-        <p:spPr>
-          <a:xfrm>
-            <a:off x="457200" y="6263640"/>
-            <a:ext cx="10972800" cy="457200"/>
-          </a:xfrm>
-          <a:prstGeom prst="rect">
-            <a:avLst/>
-          </a:prstGeom>
-          <a:noFill/>
-        </p:spPr>
-        <p:txBody>
-          <a:bodyPr wrap="none">
-            <a:spAutoFit/>
-          </a:bodyPr>
-          <a:lstStyle/>
-          <a:p>
-            <a:r>
-              <a:rPr sz="1400">
+          <p:cNvPr id="23" name="TextBox 22"/>
+          <p:cNvSpPr txBox="1"/>
+          <p:nvPr/>
+        </p:nvSpPr>
+        <p:spPr>
+          <a:xfrm>
+            <a:off x="365760" y="6601968"/>
+            <a:ext cx="10972800" cy="228600"/>
+          </a:xfrm>
+          <a:prstGeom prst="rect">
+            <a:avLst/>
+          </a:prstGeom>
+          <a:noFill/>
+        </p:spPr>
+        <p:txBody>
+          <a:bodyPr wrap="square">
+            <a:spAutoFit/>
+          </a:bodyPr>
+          <a:lstStyle/>
+          <a:p>
+            <a:r>
+              <a:rPr sz="1000" b="0" i="0">
                 <a:solidFill>
                   <a:srgbClr val="AAAABB"/>
                 </a:solidFill>
               </a:rPr>
-              <a:t>统一沉淀 | 检索复用 | 增值数字资产</a:t>
+              <a:t>来源：Aki聊AI  |  对比：咱们方案</a:t>
             </a:r>
           </a:p>
         </p:txBody>
@@ -8812,7 +10741,7 @@
         <p:spPr>
           <a:xfrm>
             <a:off x="0" y="0"/>
-            <a:ext cx="12188952" cy="1005840"/>
+            <a:ext cx="12188952" cy="822960"/>
           </a:xfrm>
           <a:prstGeom prst="rect">
             <a:avLst/>
@@ -8854,34 +10783,67 @@
         </p:nvSpPr>
         <p:spPr>
           <a:xfrm>
-            <a:off x="457200" y="137160"/>
-            <a:ext cx="10972800" cy="731520"/>
-          </a:xfrm>
-          <a:prstGeom prst="rect">
-            <a:avLst/>
-          </a:prstGeom>
-          <a:noFill/>
-        </p:spPr>
-        <p:txBody>
-          <a:bodyPr wrap="none">
-            <a:spAutoFit/>
-          </a:bodyPr>
-          <a:lstStyle/>
-          <a:p>
-            <a:r>
-              <a:rPr sz="2600" b="1">
+            <a:off x="365760" y="91440"/>
+            <a:ext cx="7315200" cy="640080"/>
+          </a:xfrm>
+          <a:prstGeom prst="rect">
+            <a:avLst/>
+          </a:prstGeom>
+          <a:noFill/>
+        </p:spPr>
+        <p:txBody>
+          <a:bodyPr wrap="square">
+            <a:spAutoFit/>
+          </a:bodyPr>
+          <a:lstStyle/>
+          <a:p>
+            <a:r>
+              <a:rPr sz="2200" b="1" i="0">
                 <a:solidFill>
                   <a:srgbClr val="6C5CF5"/>
                 </a:solidFill>
               </a:rPr>
               <a:t>📊 四工具详情</a:t>
+            </a:r>
+          </a:p>
+        </p:txBody>
+      </p:sp>
+      <p:sp>
+        <p:nvSpPr>
+          <p:cNvPr id="4" name="TextBox 3"/>
+          <p:cNvSpPr txBox="1"/>
+          <p:nvPr/>
+        </p:nvSpPr>
+        <p:spPr>
+          <a:xfrm>
+            <a:off x="7772400" y="137160"/>
+            <a:ext cx="4114800" cy="548640"/>
+          </a:xfrm>
+          <a:prstGeom prst="rect">
+            <a:avLst/>
+          </a:prstGeom>
+          <a:noFill/>
+        </p:spPr>
+        <p:txBody>
+          <a:bodyPr wrap="square">
+            <a:spAutoFit/>
+          </a:bodyPr>
+          <a:lstStyle/>
+          <a:p>
+            <a:r>
+              <a:rPr sz="1300" b="0" i="0">
+                <a:solidFill>
+                  <a:srgbClr val="AAAABB"/>
+                </a:solidFill>
+              </a:rPr>
+              <a:t>图里方案 vs 咱们方案</a:t>
             </a:r>
           </a:p>
         </p:txBody>
       </p:sp>
       <p:pic>
         <p:nvPicPr>
-          <p:cNvPr id="4" name="Picture 3" descr="知识库参考图_4_四工具详情.jpg"/>
+          <p:cNvPr id="5" name="Picture 4" descr="知识库参考图_4_四工具详情.jpg"/>
           <p:cNvPicPr>
             <a:picLocks noChangeAspect="1"/>
           </p:cNvPicPr>
@@ -8895,8 +10857,8 @@
         </p:blipFill>
         <p:spPr>
           <a:xfrm>
-            <a:off x="274320" y="1188720"/>
-            <a:ext cx="11612880" cy="4846320"/>
+            <a:off x="182880" y="914400"/>
+            <a:ext cx="6583680" cy="5669280"/>
           </a:xfrm>
           <a:prstGeom prst="rect">
             <a:avLst/>
@@ -8905,14 +10867,645 @@
       </p:pic>
       <p:sp>
         <p:nvSpPr>
-          <p:cNvPr id="5" name="Rectangle 4"/>
+          <p:cNvPr id="6" name="Rectangle 5"/>
           <p:cNvSpPr/>
           <p:nvPr/>
         </p:nvSpPr>
         <p:spPr>
           <a:xfrm>
-            <a:off x="0" y="6217920"/>
-            <a:ext cx="12188952" cy="640080"/>
+            <a:off x="6903720" y="914400"/>
+            <a:ext cx="36576" cy="5669280"/>
+          </a:xfrm>
+          <a:prstGeom prst="rect">
+            <a:avLst/>
+          </a:prstGeom>
+          <a:solidFill>
+            <a:srgbClr val="4A4A7A"/>
+          </a:solidFill>
+          <a:ln>
+            <a:noFill/>
+          </a:ln>
+        </p:spPr>
+        <p:style>
+          <a:lnRef idx="1">
+            <a:schemeClr val="accent1"/>
+          </a:lnRef>
+          <a:fillRef idx="3">
+            <a:schemeClr val="accent1"/>
+          </a:fillRef>
+          <a:effectRef idx="2">
+            <a:schemeClr val="accent1"/>
+          </a:effectRef>
+          <a:fontRef idx="minor">
+            <a:schemeClr val="lt1"/>
+          </a:fontRef>
+        </p:style>
+        <p:txBody>
+          <a:bodyPr rtlCol="0" anchor="ctr"/>
+          <a:lstStyle/>
+          <a:p>
+            <a:pPr algn="ctr"/>
+          </a:p>
+        </p:txBody>
+      </p:sp>
+      <p:sp>
+        <p:nvSpPr>
+          <p:cNvPr id="7" name="Rectangle 6"/>
+          <p:cNvSpPr/>
+          <p:nvPr/>
+        </p:nvSpPr>
+        <p:spPr>
+          <a:xfrm>
+            <a:off x="6949440" y="914400"/>
+            <a:ext cx="5120640" cy="457200"/>
+          </a:xfrm>
+          <a:prstGeom prst="rect">
+            <a:avLst/>
+          </a:prstGeom>
+          <a:solidFill>
+            <a:srgbClr val="1E1E3E"/>
+          </a:solidFill>
+          <a:ln>
+            <a:noFill/>
+          </a:ln>
+        </p:spPr>
+        <p:style>
+          <a:lnRef idx="1">
+            <a:schemeClr val="accent1"/>
+          </a:lnRef>
+          <a:fillRef idx="3">
+            <a:schemeClr val="accent1"/>
+          </a:fillRef>
+          <a:effectRef idx="2">
+            <a:schemeClr val="accent1"/>
+          </a:effectRef>
+          <a:fontRef idx="minor">
+            <a:schemeClr val="lt1"/>
+          </a:fontRef>
+        </p:style>
+        <p:txBody>
+          <a:bodyPr rtlCol="0" anchor="ctr"/>
+          <a:lstStyle/>
+          <a:p>
+            <a:pPr algn="ctr"/>
+          </a:p>
+        </p:txBody>
+      </p:sp>
+      <p:sp>
+        <p:nvSpPr>
+          <p:cNvPr id="8" name="TextBox 7"/>
+          <p:cNvSpPr txBox="1"/>
+          <p:nvPr/>
+        </p:nvSpPr>
+        <p:spPr>
+          <a:xfrm>
+            <a:off x="7040880" y="960120"/>
+            <a:ext cx="4846320" cy="365760"/>
+          </a:xfrm>
+          <a:prstGeom prst="rect">
+            <a:avLst/>
+          </a:prstGeom>
+          <a:noFill/>
+        </p:spPr>
+        <p:txBody>
+          <a:bodyPr wrap="square">
+            <a:spAutoFit/>
+          </a:bodyPr>
+          <a:lstStyle/>
+          <a:p>
+            <a:r>
+              <a:rPr sz="1300" b="1" i="0">
+                <a:solidFill>
+                  <a:srgbClr val="4EFF9C"/>
+                </a:solidFill>
+              </a:rPr>
+              <a:t>🚀 咱们方案的升级点</a:t>
+            </a:r>
+          </a:p>
+        </p:txBody>
+      </p:sp>
+      <p:sp>
+        <p:nvSpPr>
+          <p:cNvPr id="9" name="Rectangle 8"/>
+          <p:cNvSpPr/>
+          <p:nvPr/>
+        </p:nvSpPr>
+        <p:spPr>
+          <a:xfrm>
+            <a:off x="6949440" y="1417320"/>
+            <a:ext cx="5120640" cy="411480"/>
+          </a:xfrm>
+          <a:prstGeom prst="rect">
+            <a:avLst/>
+          </a:prstGeom>
+          <a:solidFill>
+            <a:srgbClr val="222244"/>
+          </a:solidFill>
+          <a:ln>
+            <a:noFill/>
+          </a:ln>
+        </p:spPr>
+        <p:style>
+          <a:lnRef idx="1">
+            <a:schemeClr val="accent1"/>
+          </a:lnRef>
+          <a:fillRef idx="3">
+            <a:schemeClr val="accent1"/>
+          </a:fillRef>
+          <a:effectRef idx="2">
+            <a:schemeClr val="accent1"/>
+          </a:effectRef>
+          <a:fontRef idx="minor">
+            <a:schemeClr val="lt1"/>
+          </a:fontRef>
+        </p:style>
+        <p:txBody>
+          <a:bodyPr rtlCol="0" anchor="ctr"/>
+          <a:lstStyle/>
+          <a:p>
+            <a:pPr algn="ctr"/>
+          </a:p>
+        </p:txBody>
+      </p:sp>
+      <p:sp>
+        <p:nvSpPr>
+          <p:cNvPr id="10" name="TextBox 9"/>
+          <p:cNvSpPr txBox="1"/>
+          <p:nvPr/>
+        </p:nvSpPr>
+        <p:spPr>
+          <a:xfrm>
+            <a:off x="7040880" y="1463040"/>
+            <a:ext cx="4846320" cy="320040"/>
+          </a:xfrm>
+          <a:prstGeom prst="rect">
+            <a:avLst/>
+          </a:prstGeom>
+          <a:noFill/>
+        </p:spPr>
+        <p:txBody>
+          <a:bodyPr wrap="square">
+            <a:spAutoFit/>
+          </a:bodyPr>
+          <a:lstStyle/>
+          <a:p>
+            <a:r>
+              <a:rPr sz="1100" b="0" i="0">
+                <a:solidFill>
+                  <a:srgbClr val="AAAABB"/>
+                </a:solidFill>
+              </a:rPr>
+              <a:t>拉进来 / 查出来 / 选出来 / 讲出去</a:t>
+            </a:r>
+          </a:p>
+        </p:txBody>
+      </p:sp>
+      <p:sp>
+        <p:nvSpPr>
+          <p:cNvPr id="11" name="Rectangle 10"/>
+          <p:cNvSpPr/>
+          <p:nvPr/>
+        </p:nvSpPr>
+        <p:spPr>
+          <a:xfrm>
+            <a:off x="6949440" y="1920240"/>
+            <a:ext cx="5120640" cy="347472"/>
+          </a:xfrm>
+          <a:prstGeom prst="rect">
+            <a:avLst/>
+          </a:prstGeom>
+          <a:solidFill>
+            <a:srgbClr val="2A2A55"/>
+          </a:solidFill>
+          <a:ln>
+            <a:noFill/>
+          </a:ln>
+        </p:spPr>
+        <p:style>
+          <a:lnRef idx="1">
+            <a:schemeClr val="accent1"/>
+          </a:lnRef>
+          <a:fillRef idx="3">
+            <a:schemeClr val="accent1"/>
+          </a:fillRef>
+          <a:effectRef idx="2">
+            <a:schemeClr val="accent1"/>
+          </a:effectRef>
+          <a:fontRef idx="minor">
+            <a:schemeClr val="lt1"/>
+          </a:fontRef>
+        </p:style>
+        <p:txBody>
+          <a:bodyPr rtlCol="0" anchor="ctr"/>
+          <a:lstStyle/>
+          <a:p>
+            <a:pPr algn="ctr"/>
+          </a:p>
+        </p:txBody>
+      </p:sp>
+      <p:sp>
+        <p:nvSpPr>
+          <p:cNvPr id="12" name="TextBox 11"/>
+          <p:cNvSpPr txBox="1"/>
+          <p:nvPr/>
+        </p:nvSpPr>
+        <p:spPr>
+          <a:xfrm>
+            <a:off x="6995160" y="1938528"/>
+            <a:ext cx="5029200" cy="310896"/>
+          </a:xfrm>
+          <a:prstGeom prst="rect">
+            <a:avLst/>
+          </a:prstGeom>
+          <a:noFill/>
+        </p:spPr>
+        <p:txBody>
+          <a:bodyPr wrap="square">
+            <a:spAutoFit/>
+          </a:bodyPr>
+          <a:lstStyle/>
+          <a:p>
+            <a:r>
+              <a:rPr sz="1200" b="1" i="0">
+                <a:solidFill>
+                  <a:srgbClr val="6C5CF5"/>
+                </a:solidFill>
+              </a:rPr>
+              <a:t>  1. 拉进来</a:t>
+            </a:r>
+          </a:p>
+        </p:txBody>
+      </p:sp>
+      <p:sp>
+        <p:nvSpPr>
+          <p:cNvPr id="13" name="TextBox 12"/>
+          <p:cNvSpPr txBox="1"/>
+          <p:nvPr/>
+        </p:nvSpPr>
+        <p:spPr>
+          <a:xfrm>
+            <a:off x="7040880" y="2286000"/>
+            <a:ext cx="5029200" cy="320040"/>
+          </a:xfrm>
+          <a:prstGeom prst="rect">
+            <a:avLst/>
+          </a:prstGeom>
+          <a:noFill/>
+        </p:spPr>
+        <p:txBody>
+          <a:bodyPr wrap="square">
+            <a:spAutoFit/>
+          </a:bodyPr>
+          <a:lstStyle/>
+          <a:p>
+            <a:r>
+              <a:rPr sz="1100" b="0" i="0">
+                <a:solidFill>
+                  <a:srgbClr val="E0E0FF"/>
+                </a:solidFill>
+              </a:rPr>
+              <a:t>    Clipper → Clippings → watcher → auto_ingest ✅</a:t>
+            </a:r>
+          </a:p>
+        </p:txBody>
+      </p:sp>
+      <p:sp>
+        <p:nvSpPr>
+          <p:cNvPr id="14" name="Rectangle 13"/>
+          <p:cNvSpPr/>
+          <p:nvPr/>
+        </p:nvSpPr>
+        <p:spPr>
+          <a:xfrm>
+            <a:off x="6949440" y="2724912"/>
+            <a:ext cx="5120640" cy="347472"/>
+          </a:xfrm>
+          <a:prstGeom prst="rect">
+            <a:avLst/>
+          </a:prstGeom>
+          <a:solidFill>
+            <a:srgbClr val="2A2A55"/>
+          </a:solidFill>
+          <a:ln>
+            <a:noFill/>
+          </a:ln>
+        </p:spPr>
+        <p:style>
+          <a:lnRef idx="1">
+            <a:schemeClr val="accent1"/>
+          </a:lnRef>
+          <a:fillRef idx="3">
+            <a:schemeClr val="accent1"/>
+          </a:fillRef>
+          <a:effectRef idx="2">
+            <a:schemeClr val="accent1"/>
+          </a:effectRef>
+          <a:fontRef idx="minor">
+            <a:schemeClr val="lt1"/>
+          </a:fontRef>
+        </p:style>
+        <p:txBody>
+          <a:bodyPr rtlCol="0" anchor="ctr"/>
+          <a:lstStyle/>
+          <a:p>
+            <a:pPr algn="ctr"/>
+          </a:p>
+        </p:txBody>
+      </p:sp>
+      <p:sp>
+        <p:nvSpPr>
+          <p:cNvPr id="15" name="TextBox 14"/>
+          <p:cNvSpPr txBox="1"/>
+          <p:nvPr/>
+        </p:nvSpPr>
+        <p:spPr>
+          <a:xfrm>
+            <a:off x="6995160" y="2743200"/>
+            <a:ext cx="5029200" cy="310896"/>
+          </a:xfrm>
+          <a:prstGeom prst="rect">
+            <a:avLst/>
+          </a:prstGeom>
+          <a:noFill/>
+        </p:spPr>
+        <p:txBody>
+          <a:bodyPr wrap="square">
+            <a:spAutoFit/>
+          </a:bodyPr>
+          <a:lstStyle/>
+          <a:p>
+            <a:r>
+              <a:rPr sz="1200" b="1" i="0">
+                <a:solidFill>
+                  <a:srgbClr val="6C5CF5"/>
+                </a:solidFill>
+              </a:rPr>
+              <a:t>  2. 查出来</a:t>
+            </a:r>
+          </a:p>
+        </p:txBody>
+      </p:sp>
+      <p:sp>
+        <p:nvSpPr>
+          <p:cNvPr id="16" name="TextBox 15"/>
+          <p:cNvSpPr txBox="1"/>
+          <p:nvPr/>
+        </p:nvSpPr>
+        <p:spPr>
+          <a:xfrm>
+            <a:off x="7040880" y="3090672"/>
+            <a:ext cx="5029200" cy="320040"/>
+          </a:xfrm>
+          <a:prstGeom prst="rect">
+            <a:avLst/>
+          </a:prstGeom>
+          <a:noFill/>
+        </p:spPr>
+        <p:txBody>
+          <a:bodyPr wrap="square">
+            <a:spAutoFit/>
+          </a:bodyPr>
+          <a:lstStyle/>
+          <a:p>
+            <a:r>
+              <a:rPr sz="1100" b="0" i="0">
+                <a:solidFill>
+                  <a:srgbClr val="E0E0FF"/>
+                </a:solidFill>
+              </a:rPr>
+              <a:t>    Dataview 查询 ✅ + QMD 语义搜索（待重启 Gateway）</a:t>
+            </a:r>
+          </a:p>
+        </p:txBody>
+      </p:sp>
+      <p:sp>
+        <p:nvSpPr>
+          <p:cNvPr id="17" name="Rectangle 16"/>
+          <p:cNvSpPr/>
+          <p:nvPr/>
+        </p:nvSpPr>
+        <p:spPr>
+          <a:xfrm>
+            <a:off x="6949440" y="3529584"/>
+            <a:ext cx="5120640" cy="347472"/>
+          </a:xfrm>
+          <a:prstGeom prst="rect">
+            <a:avLst/>
+          </a:prstGeom>
+          <a:solidFill>
+            <a:srgbClr val="2A2A55"/>
+          </a:solidFill>
+          <a:ln>
+            <a:noFill/>
+          </a:ln>
+        </p:spPr>
+        <p:style>
+          <a:lnRef idx="1">
+            <a:schemeClr val="accent1"/>
+          </a:lnRef>
+          <a:fillRef idx="3">
+            <a:schemeClr val="accent1"/>
+          </a:fillRef>
+          <a:effectRef idx="2">
+            <a:schemeClr val="accent1"/>
+          </a:effectRef>
+          <a:fontRef idx="minor">
+            <a:schemeClr val="lt1"/>
+          </a:fontRef>
+        </p:style>
+        <p:txBody>
+          <a:bodyPr rtlCol="0" anchor="ctr"/>
+          <a:lstStyle/>
+          <a:p>
+            <a:pPr algn="ctr"/>
+          </a:p>
+        </p:txBody>
+      </p:sp>
+      <p:sp>
+        <p:nvSpPr>
+          <p:cNvPr id="18" name="TextBox 17"/>
+          <p:cNvSpPr txBox="1"/>
+          <p:nvPr/>
+        </p:nvSpPr>
+        <p:spPr>
+          <a:xfrm>
+            <a:off x="6995160" y="3547872"/>
+            <a:ext cx="5029200" cy="310896"/>
+          </a:xfrm>
+          <a:prstGeom prst="rect">
+            <a:avLst/>
+          </a:prstGeom>
+          <a:noFill/>
+        </p:spPr>
+        <p:txBody>
+          <a:bodyPr wrap="square">
+            <a:spAutoFit/>
+          </a:bodyPr>
+          <a:lstStyle/>
+          <a:p>
+            <a:r>
+              <a:rPr sz="1200" b="1" i="0">
+                <a:solidFill>
+                  <a:srgbClr val="6C5CF5"/>
+                </a:solidFill>
+              </a:rPr>
+              <a:t>  3. 选出来</a:t>
+            </a:r>
+          </a:p>
+        </p:txBody>
+      </p:sp>
+      <p:sp>
+        <p:nvSpPr>
+          <p:cNvPr id="19" name="TextBox 18"/>
+          <p:cNvSpPr txBox="1"/>
+          <p:nvPr/>
+        </p:nvSpPr>
+        <p:spPr>
+          <a:xfrm>
+            <a:off x="7040880" y="3895344"/>
+            <a:ext cx="5029200" cy="320040"/>
+          </a:xfrm>
+          <a:prstGeom prst="rect">
+            <a:avLst/>
+          </a:prstGeom>
+          <a:noFill/>
+        </p:spPr>
+        <p:txBody>
+          <a:bodyPr wrap="square">
+            <a:spAutoFit/>
+          </a:bodyPr>
+          <a:lstStyle/>
+          <a:p>
+            <a:r>
+              <a:rPr sz="1100" b="0" i="0">
+                <a:solidFill>
+                  <a:srgbClr val="E0E0FF"/>
+                </a:solidFill>
+              </a:rPr>
+              <a:t>    D3.js 自定义图谱 ✅（比 Obsidian 原生更强）</a:t>
+            </a:r>
+          </a:p>
+        </p:txBody>
+      </p:sp>
+      <p:sp>
+        <p:nvSpPr>
+          <p:cNvPr id="20" name="Rectangle 19"/>
+          <p:cNvSpPr/>
+          <p:nvPr/>
+        </p:nvSpPr>
+        <p:spPr>
+          <a:xfrm>
+            <a:off x="6949440" y="4334255"/>
+            <a:ext cx="5120640" cy="347472"/>
+          </a:xfrm>
+          <a:prstGeom prst="rect">
+            <a:avLst/>
+          </a:prstGeom>
+          <a:solidFill>
+            <a:srgbClr val="2A2A55"/>
+          </a:solidFill>
+          <a:ln>
+            <a:noFill/>
+          </a:ln>
+        </p:spPr>
+        <p:style>
+          <a:lnRef idx="1">
+            <a:schemeClr val="accent1"/>
+          </a:lnRef>
+          <a:fillRef idx="3">
+            <a:schemeClr val="accent1"/>
+          </a:fillRef>
+          <a:effectRef idx="2">
+            <a:schemeClr val="accent1"/>
+          </a:effectRef>
+          <a:fontRef idx="minor">
+            <a:schemeClr val="lt1"/>
+          </a:fontRef>
+        </p:style>
+        <p:txBody>
+          <a:bodyPr rtlCol="0" anchor="ctr"/>
+          <a:lstStyle/>
+          <a:p>
+            <a:pPr algn="ctr"/>
+          </a:p>
+        </p:txBody>
+      </p:sp>
+      <p:sp>
+        <p:nvSpPr>
+          <p:cNvPr id="21" name="TextBox 20"/>
+          <p:cNvSpPr txBox="1"/>
+          <p:nvPr/>
+        </p:nvSpPr>
+        <p:spPr>
+          <a:xfrm>
+            <a:off x="6995160" y="4352543"/>
+            <a:ext cx="5029200" cy="310896"/>
+          </a:xfrm>
+          <a:prstGeom prst="rect">
+            <a:avLst/>
+          </a:prstGeom>
+          <a:noFill/>
+        </p:spPr>
+        <p:txBody>
+          <a:bodyPr wrap="square">
+            <a:spAutoFit/>
+          </a:bodyPr>
+          <a:lstStyle/>
+          <a:p>
+            <a:r>
+              <a:rPr sz="1200" b="1" i="0">
+                <a:solidFill>
+                  <a:srgbClr val="6C5CF5"/>
+                </a:solidFill>
+              </a:rPr>
+              <a:t>  4. 讲出去</a:t>
+            </a:r>
+          </a:p>
+        </p:txBody>
+      </p:sp>
+      <p:sp>
+        <p:nvSpPr>
+          <p:cNvPr id="22" name="TextBox 21"/>
+          <p:cNvSpPr txBox="1"/>
+          <p:nvPr/>
+        </p:nvSpPr>
+        <p:spPr>
+          <a:xfrm>
+            <a:off x="7040880" y="4700016"/>
+            <a:ext cx="5029200" cy="320040"/>
+          </a:xfrm>
+          <a:prstGeom prst="rect">
+            <a:avLst/>
+          </a:prstGeom>
+          <a:noFill/>
+        </p:spPr>
+        <p:txBody>
+          <a:bodyPr wrap="square">
+            <a:spAutoFit/>
+          </a:bodyPr>
+          <a:lstStyle/>
+          <a:p>
+            <a:r>
+              <a:rPr sz="1100" b="0" i="0">
+                <a:solidFill>
+                  <a:srgbClr val="E0E0FF"/>
+                </a:solidFill>
+              </a:rPr>
+              <a:t>    python-pptx 自动生成 PPT ✅</a:t>
+            </a:r>
+          </a:p>
+        </p:txBody>
+      </p:sp>
+      <p:sp>
+        <p:nvSpPr>
+          <p:cNvPr id="23" name="Rectangle 22"/>
+          <p:cNvSpPr/>
+          <p:nvPr/>
+        </p:nvSpPr>
+        <p:spPr>
+          <a:xfrm>
+            <a:off x="0" y="6583680"/>
+            <a:ext cx="12188952" cy="274320"/>
           </a:xfrm>
           <a:prstGeom prst="rect">
             <a:avLst/>
@@ -8948,33 +11541,33 @@
       </p:sp>
       <p:sp>
         <p:nvSpPr>
-          <p:cNvPr id="6" name="TextBox 5"/>
-          <p:cNvSpPr txBox="1"/>
-          <p:nvPr/>
-        </p:nvSpPr>
-        <p:spPr>
-          <a:xfrm>
-            <a:off x="457200" y="6263640"/>
-            <a:ext cx="10972800" cy="457200"/>
-          </a:xfrm>
-          <a:prstGeom prst="rect">
-            <a:avLst/>
-          </a:prstGeom>
-          <a:noFill/>
-        </p:spPr>
-        <p:txBody>
-          <a:bodyPr wrap="none">
-            <a:spAutoFit/>
-          </a:bodyPr>
-          <a:lstStyle/>
-          <a:p>
-            <a:r>
-              <a:rPr sz="1400">
+          <p:cNvPr id="24" name="TextBox 23"/>
+          <p:cNvSpPr txBox="1"/>
+          <p:nvPr/>
+        </p:nvSpPr>
+        <p:spPr>
+          <a:xfrm>
+            <a:off x="365760" y="6601968"/>
+            <a:ext cx="10972800" cy="228600"/>
+          </a:xfrm>
+          <a:prstGeom prst="rect">
+            <a:avLst/>
+          </a:prstGeom>
+          <a:noFill/>
+        </p:spPr>
+        <p:txBody>
+          <a:bodyPr wrap="square">
+            <a:spAutoFit/>
+          </a:bodyPr>
+          <a:lstStyle/>
+          <a:p>
+            <a:r>
+              <a:rPr sz="1000" b="0" i="0">
                 <a:solidFill>
                   <a:srgbClr val="AAAABB"/>
                 </a:solidFill>
               </a:rPr>
-              <a:t>拉进来(Clipper) | 查出来(Dataview) | 选出来(Graph) | 讲出去(Marp)</a:t>
+              <a:t>来源：Aki聊AI  |  对比：咱们方案</a:t>
             </a:r>
           </a:p>
         </p:txBody>

</xml_diff>